<commit_message>
changes deployed to Production
</commit_message>
<xml_diff>
--- a/ALR-DocgenTemplates/CertificateBackground_MH.pptx
+++ b/ALR-DocgenTemplates/CertificateBackground_MH.pptx
@@ -272,7 +272,7 @@
           <a:p>
             <a:fld id="{E0C45857-5204-4055-BBBB-5D81F6C0DEE1}" type="datetimeFigureOut">
               <a:rPr lang="en-US" smtClean="0"/>
-              <a:t>8/7/2024</a:t>
+              <a:t>9/2/2025</a:t>
             </a:fld>
             <a:endParaRPr lang="en-US"/>
           </a:p>
@@ -442,7 +442,7 @@
           <a:p>
             <a:fld id="{E0C45857-5204-4055-BBBB-5D81F6C0DEE1}" type="datetimeFigureOut">
               <a:rPr lang="en-US" smtClean="0"/>
-              <a:t>8/7/2024</a:t>
+              <a:t>9/2/2025</a:t>
             </a:fld>
             <a:endParaRPr lang="en-US"/>
           </a:p>
@@ -622,7 +622,7 @@
           <a:p>
             <a:fld id="{E0C45857-5204-4055-BBBB-5D81F6C0DEE1}" type="datetimeFigureOut">
               <a:rPr lang="en-US" smtClean="0"/>
-              <a:t>8/7/2024</a:t>
+              <a:t>9/2/2025</a:t>
             </a:fld>
             <a:endParaRPr lang="en-US"/>
           </a:p>
@@ -792,7 +792,7 @@
           <a:p>
             <a:fld id="{E0C45857-5204-4055-BBBB-5D81F6C0DEE1}" type="datetimeFigureOut">
               <a:rPr lang="en-US" smtClean="0"/>
-              <a:t>8/7/2024</a:t>
+              <a:t>9/2/2025</a:t>
             </a:fld>
             <a:endParaRPr lang="en-US"/>
           </a:p>
@@ -1036,7 +1036,7 @@
           <a:p>
             <a:fld id="{E0C45857-5204-4055-BBBB-5D81F6C0DEE1}" type="datetimeFigureOut">
               <a:rPr lang="en-US" smtClean="0"/>
-              <a:t>8/7/2024</a:t>
+              <a:t>9/2/2025</a:t>
             </a:fld>
             <a:endParaRPr lang="en-US"/>
           </a:p>
@@ -1268,7 +1268,7 @@
           <a:p>
             <a:fld id="{E0C45857-5204-4055-BBBB-5D81F6C0DEE1}" type="datetimeFigureOut">
               <a:rPr lang="en-US" smtClean="0"/>
-              <a:t>8/7/2024</a:t>
+              <a:t>9/2/2025</a:t>
             </a:fld>
             <a:endParaRPr lang="en-US"/>
           </a:p>
@@ -1635,7 +1635,7 @@
           <a:p>
             <a:fld id="{E0C45857-5204-4055-BBBB-5D81F6C0DEE1}" type="datetimeFigureOut">
               <a:rPr lang="en-US" smtClean="0"/>
-              <a:t>8/7/2024</a:t>
+              <a:t>9/2/2025</a:t>
             </a:fld>
             <a:endParaRPr lang="en-US"/>
           </a:p>
@@ -1753,7 +1753,7 @@
           <a:p>
             <a:fld id="{E0C45857-5204-4055-BBBB-5D81F6C0DEE1}" type="datetimeFigureOut">
               <a:rPr lang="en-US" smtClean="0"/>
-              <a:t>8/7/2024</a:t>
+              <a:t>9/2/2025</a:t>
             </a:fld>
             <a:endParaRPr lang="en-US"/>
           </a:p>
@@ -1848,7 +1848,7 @@
           <a:p>
             <a:fld id="{E0C45857-5204-4055-BBBB-5D81F6C0DEE1}" type="datetimeFigureOut">
               <a:rPr lang="en-US" smtClean="0"/>
-              <a:t>8/7/2024</a:t>
+              <a:t>9/2/2025</a:t>
             </a:fld>
             <a:endParaRPr lang="en-US"/>
           </a:p>
@@ -2125,7 +2125,7 @@
           <a:p>
             <a:fld id="{E0C45857-5204-4055-BBBB-5D81F6C0DEE1}" type="datetimeFigureOut">
               <a:rPr lang="en-US" smtClean="0"/>
-              <a:t>8/7/2024</a:t>
+              <a:t>9/2/2025</a:t>
             </a:fld>
             <a:endParaRPr lang="en-US"/>
           </a:p>
@@ -2382,7 +2382,7 @@
           <a:p>
             <a:fld id="{E0C45857-5204-4055-BBBB-5D81F6C0DEE1}" type="datetimeFigureOut">
               <a:rPr lang="en-US" smtClean="0"/>
-              <a:t>8/7/2024</a:t>
+              <a:t>9/2/2025</a:t>
             </a:fld>
             <a:endParaRPr lang="en-US"/>
           </a:p>
@@ -2595,7 +2595,7 @@
           <a:p>
             <a:fld id="{E0C45857-5204-4055-BBBB-5D81F6C0DEE1}" type="datetimeFigureOut">
               <a:rPr lang="en-US" smtClean="0"/>
-              <a:t>8/7/2024</a:t>
+              <a:t>9/2/2025</a:t>
             </a:fld>
             <a:endParaRPr lang="en-US"/>
           </a:p>
@@ -3076,7 +3076,7 @@
         </p:blipFill>
         <p:spPr bwMode="auto">
           <a:xfrm>
-            <a:off x="-33338" y="-6003"/>
+            <a:off x="-57248" y="16575"/>
             <a:ext cx="10125076" cy="7784407"/>
           </a:xfrm>
           <a:prstGeom prst="rect">
@@ -3509,8 +3509,8 @@
         </p:nvSpPr>
         <p:spPr>
           <a:xfrm>
-            <a:off x="2270224" y="2228850"/>
-            <a:ext cx="7391135" cy="4041043"/>
+            <a:off x="2154613" y="1695910"/>
+            <a:ext cx="8732638" cy="1865382"/>
           </a:xfrm>
           <a:prstGeom prst="rect">
             <a:avLst/>
@@ -3541,7 +3541,7 @@
               <a:t>{{</a:t>
             </a:r>
             <a:r>
-              <a:rPr lang="en-US" sz="2400" b="1" dirty="0" err="1">
+              <a:rPr lang="en-US" sz="2200" b="1" dirty="0" err="1">
                 <a:solidFill>
                   <a:srgbClr val="3B305B"/>
                 </a:solidFill>
@@ -3642,7 +3642,7 @@
               </a:spcAft>
             </a:pPr>
             <a:r>
-              <a:rPr lang="en-US" dirty="0">
+              <a:rPr lang="en-US" sz="1600" dirty="0">
                 <a:solidFill>
                   <a:srgbClr val="3B305B"/>
                 </a:solidFill>
@@ -3654,7 +3654,7 @@
               <a:t>{{</a:t>
             </a:r>
             <a:r>
-              <a:rPr lang="en-US" dirty="0" err="1">
+              <a:rPr lang="en-US" sz="1600" dirty="0" err="1">
                 <a:solidFill>
                   <a:srgbClr val="3B305B"/>
                 </a:solidFill>
@@ -3666,7 +3666,7 @@
               <a:t>ResidenceAddress</a:t>
             </a:r>
             <a:r>
-              <a:rPr lang="en-US" dirty="0">
+              <a:rPr lang="en-US" sz="1600" dirty="0">
                 <a:solidFill>
                   <a:srgbClr val="3B305B"/>
                 </a:solidFill>
@@ -3829,155 +3829,6 @@
               <a:t>}}</a:t>
             </a:r>
           </a:p>
-          <a:p>
-            <a:pPr marL="1496060" marR="3183255">
-              <a:lnSpc>
-                <a:spcPct val="123000"/>
-              </a:lnSpc>
-              <a:spcBef>
-                <a:spcPts val="515"/>
-              </a:spcBef>
-            </a:pPr>
-            <a:endParaRPr lang="en-US" sz="1400" dirty="0">
-              <a:effectLst/>
-              <a:latin typeface="BC Sans"/>
-              <a:ea typeface="Verdana" panose="020B0604030504040204" pitchFamily="34" charset="0"/>
-              <a:cs typeface="Verdana" panose="020B0604030504040204" pitchFamily="34" charset="0"/>
-            </a:endParaRPr>
-          </a:p>
-          <a:p>
-            <a:pPr marL="1496060" marR="3183255">
-              <a:lnSpc>
-                <a:spcPct val="123000"/>
-              </a:lnSpc>
-              <a:spcBef>
-                <a:spcPts val="515"/>
-              </a:spcBef>
-            </a:pPr>
-            <a:r>
-              <a:rPr lang="en-US" sz="1400" dirty="0">
-                <a:solidFill>
-                  <a:srgbClr val="3B305B"/>
-                </a:solidFill>
-                <a:latin typeface="BC Sans"/>
-                <a:ea typeface="Verdana" panose="020B0604030504040204" pitchFamily="34" charset="0"/>
-              </a:rPr>
-              <a:t>Assisted Living Service(s): {{</a:t>
-            </a:r>
-            <a:r>
-              <a:rPr lang="en-US" sz="1400" b="0" dirty="0">
-                <a:solidFill>
-                  <a:srgbClr val="A31515"/>
-                </a:solidFill>
-                <a:effectLst/>
-                <a:latin typeface="Consolas" panose="020B0609020204030204" pitchFamily="49" charset="0"/>
-              </a:rPr>
-              <a:t>Services</a:t>
-            </a:r>
-            <a:r>
-              <a:rPr lang="en-US" sz="1400" dirty="0">
-                <a:solidFill>
-                  <a:srgbClr val="3B305B"/>
-                </a:solidFill>
-                <a:latin typeface="BC Sans"/>
-                <a:ea typeface="Verdana" panose="020B0604030504040204" pitchFamily="34" charset="0"/>
-              </a:rPr>
-              <a:t>}}</a:t>
-            </a:r>
-          </a:p>
-          <a:p>
-            <a:pPr marL="1496060" marR="3183255">
-              <a:lnSpc>
-                <a:spcPct val="123000"/>
-              </a:lnSpc>
-              <a:spcBef>
-                <a:spcPts val="515"/>
-              </a:spcBef>
-            </a:pPr>
-            <a:endParaRPr lang="en-US" sz="1400" dirty="0">
-              <a:solidFill>
-                <a:srgbClr val="3B305B"/>
-              </a:solidFill>
-              <a:latin typeface="BC Sans"/>
-              <a:ea typeface="Verdana" panose="020B0604030504040204" pitchFamily="34" charset="0"/>
-            </a:endParaRPr>
-          </a:p>
-          <a:p>
-            <a:pPr marL="1496060" marR="3183255">
-              <a:lnSpc>
-                <a:spcPct val="123000"/>
-              </a:lnSpc>
-              <a:spcBef>
-                <a:spcPts val="515"/>
-              </a:spcBef>
-            </a:pPr>
-            <a:r>
-              <a:rPr lang="en-US" sz="1400" b="1">
-                <a:solidFill>
-                  <a:srgbClr val="3B305B"/>
-                </a:solidFill>
-                <a:latin typeface="BC Sans"/>
-                <a:ea typeface="Verdana" panose="020B0604030504040204" pitchFamily="34" charset="0"/>
-              </a:rPr>
-              <a:t>CONDITIONS:</a:t>
-            </a:r>
-          </a:p>
-          <a:p>
-            <a:pPr marL="1496060" marR="3183255">
-              <a:lnSpc>
-                <a:spcPct val="123000"/>
-              </a:lnSpc>
-              <a:spcBef>
-                <a:spcPts val="515"/>
-              </a:spcBef>
-            </a:pPr>
-            <a:r>
-              <a:rPr lang="en-US" sz="1400" b="1">
-                <a:solidFill>
-                  <a:srgbClr val="3B305B"/>
-                </a:solidFill>
-                <a:latin typeface="BC Sans"/>
-                <a:ea typeface="Verdana" panose="020B0604030504040204" pitchFamily="34" charset="0"/>
-              </a:rPr>
-              <a:t>{{</a:t>
-            </a:r>
-            <a:r>
-              <a:rPr lang="en-US" sz="1400" b="1" dirty="0" err="1">
-                <a:solidFill>
-                  <a:srgbClr val="3B305B"/>
-                </a:solidFill>
-                <a:latin typeface="BC Sans"/>
-                <a:ea typeface="Verdana" panose="020B0604030504040204" pitchFamily="34" charset="0"/>
-              </a:rPr>
-              <a:t>ConditionAndDescription</a:t>
-            </a:r>
-            <a:r>
-              <a:rPr lang="en-US" sz="1400" b="1" dirty="0">
-                <a:solidFill>
-                  <a:srgbClr val="3B305B"/>
-                </a:solidFill>
-                <a:latin typeface="BC Sans"/>
-                <a:ea typeface="Verdana" panose="020B0604030504040204" pitchFamily="34" charset="0"/>
-              </a:rPr>
-              <a:t>}}</a:t>
-            </a:r>
-            <a:r>
-              <a:rPr lang="en-US" sz="1400" dirty="0">
-                <a:solidFill>
-                  <a:srgbClr val="3B305B"/>
-                </a:solidFill>
-                <a:latin typeface="BC Sans"/>
-                <a:ea typeface="Verdana" panose="020B0604030504040204" pitchFamily="34" charset="0"/>
-              </a:rPr>
-              <a:t>{{ConditionAndDescription1}}</a:t>
-            </a:r>
-            <a:endParaRPr lang="en-CA" sz="800" dirty="0">
-              <a:effectLst/>
-              <a:latin typeface="BC Sans"/>
-              <a:ea typeface="Verdana" panose="020B0604030504040204" pitchFamily="34" charset="0"/>
-              <a:cs typeface="Verdana" panose="020B0604030504040204" pitchFamily="34" charset="0"/>
-            </a:endParaRPr>
-          </a:p>
         </p:txBody>
       </p:sp>
       <p:sp>
@@ -3994,8 +3845,8 @@
         </p:nvSpPr>
         <p:spPr>
           <a:xfrm>
-            <a:off x="1684421" y="781125"/>
-            <a:ext cx="8469856" cy="461665"/>
+            <a:off x="1684421" y="676025"/>
+            <a:ext cx="8469856" cy="430887"/>
           </a:xfrm>
           <a:prstGeom prst="rect">
             <a:avLst/>
@@ -4014,7 +3865,7 @@
               </a:spcBef>
             </a:pPr>
             <a:r>
-              <a:rPr lang="en-US" sz="2400" b="1" dirty="0">
+              <a:rPr lang="en-US" sz="2200" b="1" dirty="0">
                 <a:solidFill>
                   <a:srgbClr val="3B305B"/>
                 </a:solidFill>
@@ -4042,7 +3893,7 @@
         </p:nvSpPr>
         <p:spPr>
           <a:xfrm>
-            <a:off x="5654842" y="6486412"/>
+            <a:off x="6149710" y="6486412"/>
             <a:ext cx="2442411" cy="738664"/>
           </a:xfrm>
           <a:prstGeom prst="rect">
@@ -4134,8 +3985,8 @@
         </p:nvCxnSpPr>
         <p:spPr>
           <a:xfrm>
-            <a:off x="3296653" y="1385669"/>
-            <a:ext cx="6364705" cy="0"/>
+            <a:off x="3247696" y="1291080"/>
+            <a:ext cx="6035961" cy="0"/>
           </a:xfrm>
           <a:prstGeom prst="line">
             <a:avLst/>
@@ -4217,7 +4068,7 @@
         </p:nvSpPr>
         <p:spPr>
           <a:xfrm>
-            <a:off x="7652085" y="6478400"/>
+            <a:off x="7383135" y="6478400"/>
             <a:ext cx="2683618" cy="738664"/>
           </a:xfrm>
           <a:prstGeom prst="rect">
@@ -4437,7 +4288,7 @@
         </p:blipFill>
         <p:spPr>
           <a:xfrm>
-            <a:off x="2270224" y="2214581"/>
+            <a:off x="2207164" y="1681641"/>
             <a:ext cx="1181100" cy="1181100"/>
           </a:xfrm>
           <a:prstGeom prst="rect">
@@ -4449,6 +4300,252 @@
           </a:ln>
         </p:spPr>
       </p:pic>
+      <p:sp>
+        <p:nvSpPr>
+          <p:cNvPr id="17" name="TextBox 8">
+            <a:extLst>
+              <a:ext uri="{FF2B5EF4-FFF2-40B4-BE49-F238E27FC236}">
+                <a16:creationId xmlns:a16="http://schemas.microsoft.com/office/drawing/2014/main" id="{2661C2CE-7AAD-2E59-A527-EDBEF23061BD}"/>
+              </a:ext>
+            </a:extLst>
+          </p:cNvPr>
+          <p:cNvSpPr txBox="1"/>
+          <p:nvPr/>
+        </p:nvSpPr>
+        <p:spPr>
+          <a:xfrm>
+            <a:off x="2144105" y="3722905"/>
+            <a:ext cx="10993954" cy="1212320"/>
+          </a:xfrm>
+          <a:prstGeom prst="rect">
+            <a:avLst/>
+          </a:prstGeom>
+          <a:noFill/>
+        </p:spPr>
+        <p:txBody>
+          <a:bodyPr wrap="square">
+            <a:spAutoFit/>
+          </a:bodyPr>
+          <a:lstStyle>
+            <a:defPPr>
+              <a:defRPr lang="en-US"/>
+            </a:defPPr>
+            <a:lvl1pPr marL="0" algn="l" defTabSz="457200" rtl="0" eaLnBrk="1" latinLnBrk="0" hangingPunct="1">
+              <a:defRPr sz="1800" kern="1200">
+                <a:solidFill>
+                  <a:schemeClr val="tx1"/>
+                </a:solidFill>
+                <a:latin typeface="+mn-lt"/>
+                <a:ea typeface="+mn-ea"/>
+                <a:cs typeface="+mn-cs"/>
+              </a:defRPr>
+            </a:lvl1pPr>
+            <a:lvl2pPr marL="457200" algn="l" defTabSz="457200" rtl="0" eaLnBrk="1" latinLnBrk="0" hangingPunct="1">
+              <a:defRPr sz="1800" kern="1200">
+                <a:solidFill>
+                  <a:schemeClr val="tx1"/>
+                </a:solidFill>
+                <a:latin typeface="+mn-lt"/>
+                <a:ea typeface="+mn-ea"/>
+                <a:cs typeface="+mn-cs"/>
+              </a:defRPr>
+            </a:lvl2pPr>
+            <a:lvl3pPr marL="914400" algn="l" defTabSz="457200" rtl="0" eaLnBrk="1" latinLnBrk="0" hangingPunct="1">
+              <a:defRPr sz="1800" kern="1200">
+                <a:solidFill>
+                  <a:schemeClr val="tx1"/>
+                </a:solidFill>
+                <a:latin typeface="+mn-lt"/>
+                <a:ea typeface="+mn-ea"/>
+                <a:cs typeface="+mn-cs"/>
+              </a:defRPr>
+            </a:lvl3pPr>
+            <a:lvl4pPr marL="1371600" algn="l" defTabSz="457200" rtl="0" eaLnBrk="1" latinLnBrk="0" hangingPunct="1">
+              <a:defRPr sz="1800" kern="1200">
+                <a:solidFill>
+                  <a:schemeClr val="tx1"/>
+                </a:solidFill>
+                <a:latin typeface="+mn-lt"/>
+                <a:ea typeface="+mn-ea"/>
+                <a:cs typeface="+mn-cs"/>
+              </a:defRPr>
+            </a:lvl4pPr>
+            <a:lvl5pPr marL="1828800" algn="l" defTabSz="457200" rtl="0" eaLnBrk="1" latinLnBrk="0" hangingPunct="1">
+              <a:defRPr sz="1800" kern="1200">
+                <a:solidFill>
+                  <a:schemeClr val="tx1"/>
+                </a:solidFill>
+                <a:latin typeface="+mn-lt"/>
+                <a:ea typeface="+mn-ea"/>
+                <a:cs typeface="+mn-cs"/>
+              </a:defRPr>
+            </a:lvl5pPr>
+            <a:lvl6pPr marL="2286000" algn="l" defTabSz="457200" rtl="0" eaLnBrk="1" latinLnBrk="0" hangingPunct="1">
+              <a:defRPr sz="1800" kern="1200">
+                <a:solidFill>
+                  <a:schemeClr val="tx1"/>
+                </a:solidFill>
+                <a:latin typeface="+mn-lt"/>
+                <a:ea typeface="+mn-ea"/>
+                <a:cs typeface="+mn-cs"/>
+              </a:defRPr>
+            </a:lvl6pPr>
+            <a:lvl7pPr marL="2743200" algn="l" defTabSz="457200" rtl="0" eaLnBrk="1" latinLnBrk="0" hangingPunct="1">
+              <a:defRPr sz="1800" kern="1200">
+                <a:solidFill>
+                  <a:schemeClr val="tx1"/>
+                </a:solidFill>
+                <a:latin typeface="+mn-lt"/>
+                <a:ea typeface="+mn-ea"/>
+                <a:cs typeface="+mn-cs"/>
+              </a:defRPr>
+            </a:lvl7pPr>
+            <a:lvl8pPr marL="3200400" algn="l" defTabSz="457200" rtl="0" eaLnBrk="1" latinLnBrk="0" hangingPunct="1">
+              <a:defRPr sz="1800" kern="1200">
+                <a:solidFill>
+                  <a:schemeClr val="tx1"/>
+                </a:solidFill>
+                <a:latin typeface="+mn-lt"/>
+                <a:ea typeface="+mn-ea"/>
+                <a:cs typeface="+mn-cs"/>
+              </a:defRPr>
+            </a:lvl8pPr>
+            <a:lvl9pPr marL="3657600" algn="l" defTabSz="457200" rtl="0" eaLnBrk="1" latinLnBrk="0" hangingPunct="1">
+              <a:defRPr sz="1800" kern="1200">
+                <a:solidFill>
+                  <a:schemeClr val="tx1"/>
+                </a:solidFill>
+                <a:latin typeface="+mn-lt"/>
+                <a:ea typeface="+mn-ea"/>
+                <a:cs typeface="+mn-cs"/>
+              </a:defRPr>
+            </a:lvl9pPr>
+          </a:lstStyle>
+          <a:p>
+            <a:pPr marL="1496060" marR="3183255">
+              <a:lnSpc>
+                <a:spcPct val="123000"/>
+              </a:lnSpc>
+              <a:spcBef>
+                <a:spcPts val="515"/>
+              </a:spcBef>
+            </a:pPr>
+            <a:r>
+              <a:rPr lang="en-US" sz="1400" dirty="0">
+                <a:solidFill>
+                  <a:srgbClr val="3B305B"/>
+                </a:solidFill>
+                <a:latin typeface="BC Sans"/>
+                <a:ea typeface="Verdana" panose="020B0604030504040204" pitchFamily="34" charset="0"/>
+              </a:rPr>
+              <a:t>Assisted Living Service(s): {{</a:t>
+            </a:r>
+            <a:r>
+              <a:rPr lang="en-US" sz="1400" b="0" dirty="0">
+                <a:solidFill>
+                  <a:srgbClr val="A31515"/>
+                </a:solidFill>
+                <a:effectLst/>
+                <a:latin typeface="Consolas" panose="020B0609020204030204" pitchFamily="49" charset="0"/>
+              </a:rPr>
+              <a:t>Services</a:t>
+            </a:r>
+            <a:r>
+              <a:rPr lang="en-US" sz="1400" dirty="0">
+                <a:solidFill>
+                  <a:srgbClr val="3B305B"/>
+                </a:solidFill>
+                <a:latin typeface="BC Sans"/>
+                <a:ea typeface="Verdana" panose="020B0604030504040204" pitchFamily="34" charset="0"/>
+              </a:rPr>
+              <a:t>}}</a:t>
+            </a:r>
+          </a:p>
+          <a:p>
+            <a:pPr marL="1496060" marR="3183255">
+              <a:lnSpc>
+                <a:spcPct val="123000"/>
+              </a:lnSpc>
+              <a:spcBef>
+                <a:spcPts val="515"/>
+              </a:spcBef>
+            </a:pPr>
+            <a:endParaRPr lang="en-US" sz="800" dirty="0">
+              <a:solidFill>
+                <a:srgbClr val="3B305B"/>
+              </a:solidFill>
+              <a:latin typeface="BC Sans"/>
+              <a:ea typeface="Verdana" panose="020B0604030504040204" pitchFamily="34" charset="0"/>
+            </a:endParaRPr>
+          </a:p>
+          <a:p>
+            <a:pPr marL="1496060" marR="3183255">
+              <a:lnSpc>
+                <a:spcPct val="123000"/>
+              </a:lnSpc>
+              <a:spcBef>
+                <a:spcPts val="515"/>
+              </a:spcBef>
+            </a:pPr>
+            <a:r>
+              <a:rPr lang="en-US" sz="1400" b="1" dirty="0">
+                <a:solidFill>
+                  <a:srgbClr val="3B305B"/>
+                </a:solidFill>
+                <a:latin typeface="BC Sans"/>
+                <a:ea typeface="Verdana" panose="020B0604030504040204" pitchFamily="34" charset="0"/>
+              </a:rPr>
+              <a:t>CONDITIONS:</a:t>
+            </a:r>
+          </a:p>
+          <a:p>
+            <a:pPr marL="1496060" marR="3183255">
+              <a:lnSpc>
+                <a:spcPct val="123000"/>
+              </a:lnSpc>
+              <a:spcBef>
+                <a:spcPts val="515"/>
+              </a:spcBef>
+            </a:pPr>
+            <a:r>
+              <a:rPr lang="en-US" sz="1400" dirty="0">
+                <a:solidFill>
+                  <a:srgbClr val="3B305B"/>
+                </a:solidFill>
+                <a:latin typeface="BC Sans"/>
+                <a:ea typeface="Verdana" panose="020B0604030504040204" pitchFamily="34" charset="0"/>
+              </a:rPr>
+              <a:t>{{</a:t>
+            </a:r>
+            <a:r>
+              <a:rPr lang="en-US" sz="1400" dirty="0" err="1">
+                <a:solidFill>
+                  <a:srgbClr val="3B305B"/>
+                </a:solidFill>
+                <a:latin typeface="BC Sans"/>
+                <a:ea typeface="Verdana" panose="020B0604030504040204" pitchFamily="34" charset="0"/>
+              </a:rPr>
+              <a:t>ConditionAndDescription</a:t>
+            </a:r>
+            <a:r>
+              <a:rPr lang="en-US" sz="1400" dirty="0">
+                <a:solidFill>
+                  <a:srgbClr val="3B305B"/>
+                </a:solidFill>
+                <a:latin typeface="BC Sans"/>
+                <a:ea typeface="Verdana" panose="020B0604030504040204" pitchFamily="34" charset="0"/>
+              </a:rPr>
+              <a:t>}} {{ConditionAndDescription1}}</a:t>
+            </a:r>
+            <a:endParaRPr lang="en-CA" sz="800" dirty="0">
+              <a:effectLst/>
+              <a:latin typeface="BC Sans"/>
+              <a:ea typeface="Verdana" panose="020B0604030504040204" pitchFamily="34" charset="0"/>
+              <a:cs typeface="Verdana" panose="020B0604030504040204" pitchFamily="34" charset="0"/>
+            </a:endParaRPr>
+          </a:p>
+        </p:txBody>
+      </p:sp>
     </p:spTree>
     <p:extLst>
       <p:ext uri="{BB962C8B-B14F-4D97-AF65-F5344CB8AC3E}">
@@ -4725,6 +4822,7 @@
 
 <file path=docMetadata/LabelInfo.xml><?xml version="1.0" encoding="utf-8"?>
 <clbl:labelList xmlns:clbl="http://schemas.microsoft.com/office/2020/mipLabelMetadata">
+  <clbl:label id="{d9290083-bd2f-48a2-8ac5-09a524b17d15}" enabled="1" method="Privileged" siteId="{b9fec68c-c92d-461e-9a97-3d03a0f18b82}" contentBits="1" removed="0"/>
   <clbl:label id="{e0793d39-0939-496d-b129-198edd916feb}" enabled="0" method="" siteId="{e0793d39-0939-496d-b129-198edd916feb}" removed="1"/>
 </clbl:labelList>
 </file>
</xml_diff>

<commit_message>
BCMOHAD-31877 || Created the Backpromotion PR
</commit_message>
<xml_diff>
--- a/ALR-DocgenTemplates/CertificateBackground_MH.pptx
+++ b/ALR-DocgenTemplates/CertificateBackground_MH.pptx
@@ -112,35 +112,6 @@
 </p:presentation>
 </file>
 
-<file path=ppt/changesInfos/changesInfo1.xml><?xml version="1.0" encoding="utf-8"?>
-<pc:chgInfo xmlns:a="http://schemas.openxmlformats.org/drawingml/2006/main" xmlns:r="http://schemas.openxmlformats.org/officeDocument/2006/relationships" xmlns:ac="http://schemas.microsoft.com/office/drawing/2013/main/command" xmlns:pc="http://schemas.microsoft.com/office/powerpoint/2013/main/command">
-  <pc:docChgLst>
-    <pc:chgData name="Narendra Patil, Kiran" userId="bd8726b3-9de5-4981-82ea-44e4ceaf49c4" providerId="ADAL" clId="{AEC3F5A0-79AE-4B5E-8160-C5BDCC55510A}"/>
-    <pc:docChg chg="modSld">
-      <pc:chgData name="Narendra Patil, Kiran" userId="bd8726b3-9de5-4981-82ea-44e4ceaf49c4" providerId="ADAL" clId="{AEC3F5A0-79AE-4B5E-8160-C5BDCC55510A}" dt="2024-08-07T10:09:43.513" v="8" actId="20577"/>
-      <pc:docMkLst>
-        <pc:docMk/>
-      </pc:docMkLst>
-      <pc:sldChg chg="modSp mod">
-        <pc:chgData name="Narendra Patil, Kiran" userId="bd8726b3-9de5-4981-82ea-44e4ceaf49c4" providerId="ADAL" clId="{AEC3F5A0-79AE-4B5E-8160-C5BDCC55510A}" dt="2024-08-07T10:09:43.513" v="8" actId="20577"/>
-        <pc:sldMkLst>
-          <pc:docMk/>
-          <pc:sldMk cId="1830213082" sldId="256"/>
-        </pc:sldMkLst>
-        <pc:spChg chg="mod">
-          <ac:chgData name="Narendra Patil, Kiran" userId="bd8726b3-9de5-4981-82ea-44e4ceaf49c4" providerId="ADAL" clId="{AEC3F5A0-79AE-4B5E-8160-C5BDCC55510A}" dt="2024-08-07T10:09:43.513" v="8" actId="20577"/>
-          <ac:spMkLst>
-            <pc:docMk/>
-            <pc:sldMk cId="1830213082" sldId="256"/>
-            <ac:spMk id="9" creationId="{2661C2CE-7AAD-2E59-A527-EDBEF23061BD}"/>
-          </ac:spMkLst>
-        </pc:spChg>
-      </pc:sldChg>
-    </pc:docChg>
-  </pc:docChgLst>
-</pc:chgInfo>
-</file>
-
 <file path=ppt/slideLayouts/slideLayout1.xml><?xml version="1.0" encoding="utf-8"?>
 <p:sldLayout xmlns:a="http://schemas.openxmlformats.org/drawingml/2006/main" xmlns:r="http://schemas.openxmlformats.org/officeDocument/2006/relationships" xmlns:p="http://schemas.openxmlformats.org/presentationml/2006/main" type="title" preserve="1">
   <p:cSld name="Title Slide">
@@ -272,7 +243,7 @@
           <a:p>
             <a:fld id="{E0C45857-5204-4055-BBBB-5D81F6C0DEE1}" type="datetimeFigureOut">
               <a:rPr lang="en-US" smtClean="0"/>
-              <a:t>9/2/2025</a:t>
+              <a:t>4/30/2026</a:t>
             </a:fld>
             <a:endParaRPr lang="en-US"/>
           </a:p>
@@ -442,7 +413,7 @@
           <a:p>
             <a:fld id="{E0C45857-5204-4055-BBBB-5D81F6C0DEE1}" type="datetimeFigureOut">
               <a:rPr lang="en-US" smtClean="0"/>
-              <a:t>9/2/2025</a:t>
+              <a:t>4/30/2026</a:t>
             </a:fld>
             <a:endParaRPr lang="en-US"/>
           </a:p>
@@ -622,7 +593,7 @@
           <a:p>
             <a:fld id="{E0C45857-5204-4055-BBBB-5D81F6C0DEE1}" type="datetimeFigureOut">
               <a:rPr lang="en-US" smtClean="0"/>
-              <a:t>9/2/2025</a:t>
+              <a:t>4/30/2026</a:t>
             </a:fld>
             <a:endParaRPr lang="en-US"/>
           </a:p>
@@ -792,7 +763,7 @@
           <a:p>
             <a:fld id="{E0C45857-5204-4055-BBBB-5D81F6C0DEE1}" type="datetimeFigureOut">
               <a:rPr lang="en-US" smtClean="0"/>
-              <a:t>9/2/2025</a:t>
+              <a:t>4/30/2026</a:t>
             </a:fld>
             <a:endParaRPr lang="en-US"/>
           </a:p>
@@ -1036,7 +1007,7 @@
           <a:p>
             <a:fld id="{E0C45857-5204-4055-BBBB-5D81F6C0DEE1}" type="datetimeFigureOut">
               <a:rPr lang="en-US" smtClean="0"/>
-              <a:t>9/2/2025</a:t>
+              <a:t>4/30/2026</a:t>
             </a:fld>
             <a:endParaRPr lang="en-US"/>
           </a:p>
@@ -1268,7 +1239,7 @@
           <a:p>
             <a:fld id="{E0C45857-5204-4055-BBBB-5D81F6C0DEE1}" type="datetimeFigureOut">
               <a:rPr lang="en-US" smtClean="0"/>
-              <a:t>9/2/2025</a:t>
+              <a:t>4/30/2026</a:t>
             </a:fld>
             <a:endParaRPr lang="en-US"/>
           </a:p>
@@ -1635,7 +1606,7 @@
           <a:p>
             <a:fld id="{E0C45857-5204-4055-BBBB-5D81F6C0DEE1}" type="datetimeFigureOut">
               <a:rPr lang="en-US" smtClean="0"/>
-              <a:t>9/2/2025</a:t>
+              <a:t>4/30/2026</a:t>
             </a:fld>
             <a:endParaRPr lang="en-US"/>
           </a:p>
@@ -1753,7 +1724,7 @@
           <a:p>
             <a:fld id="{E0C45857-5204-4055-BBBB-5D81F6C0DEE1}" type="datetimeFigureOut">
               <a:rPr lang="en-US" smtClean="0"/>
-              <a:t>9/2/2025</a:t>
+              <a:t>4/30/2026</a:t>
             </a:fld>
             <a:endParaRPr lang="en-US"/>
           </a:p>
@@ -1848,7 +1819,7 @@
           <a:p>
             <a:fld id="{E0C45857-5204-4055-BBBB-5D81F6C0DEE1}" type="datetimeFigureOut">
               <a:rPr lang="en-US" smtClean="0"/>
-              <a:t>9/2/2025</a:t>
+              <a:t>4/30/2026</a:t>
             </a:fld>
             <a:endParaRPr lang="en-US"/>
           </a:p>
@@ -2125,7 +2096,7 @@
           <a:p>
             <a:fld id="{E0C45857-5204-4055-BBBB-5D81F6C0DEE1}" type="datetimeFigureOut">
               <a:rPr lang="en-US" smtClean="0"/>
-              <a:t>9/2/2025</a:t>
+              <a:t>4/30/2026</a:t>
             </a:fld>
             <a:endParaRPr lang="en-US"/>
           </a:p>
@@ -2382,7 +2353,7 @@
           <a:p>
             <a:fld id="{E0C45857-5204-4055-BBBB-5D81F6C0DEE1}" type="datetimeFigureOut">
               <a:rPr lang="en-US" smtClean="0"/>
-              <a:t>9/2/2025</a:t>
+              <a:t>4/30/2026</a:t>
             </a:fld>
             <a:endParaRPr lang="en-US"/>
           </a:p>
@@ -2595,7 +2566,7 @@
           <a:p>
             <a:fld id="{E0C45857-5204-4055-BBBB-5D81F6C0DEE1}" type="datetimeFigureOut">
               <a:rPr lang="en-US" smtClean="0"/>
-              <a:t>9/2/2025</a:t>
+              <a:t>4/30/2026</a:t>
             </a:fld>
             <a:endParaRPr lang="en-US"/>
           </a:p>
@@ -3076,7 +3047,7 @@
         </p:blipFill>
         <p:spPr bwMode="auto">
           <a:xfrm>
-            <a:off x="-57248" y="16575"/>
+            <a:off x="-57248" y="-17293"/>
             <a:ext cx="10125076" cy="7784407"/>
           </a:xfrm>
           <a:prstGeom prst="rect">
@@ -3492,390 +3463,6 @@
           <a:p>
             <a:pPr algn="ctr"/>
             <a:endParaRPr lang="en-US"/>
-          </a:p>
-        </p:txBody>
-      </p:sp>
-      <p:sp>
-        <p:nvSpPr>
-          <p:cNvPr id="9" name="TextBox 8">
-            <a:extLst>
-              <a:ext uri="{FF2B5EF4-FFF2-40B4-BE49-F238E27FC236}">
-                <a16:creationId xmlns:a16="http://schemas.microsoft.com/office/drawing/2014/main" id="{2661C2CE-7AAD-2E59-A527-EDBEF23061BD}"/>
-              </a:ext>
-            </a:extLst>
-          </p:cNvPr>
-          <p:cNvSpPr txBox="1"/>
-          <p:nvPr/>
-        </p:nvSpPr>
-        <p:spPr>
-          <a:xfrm>
-            <a:off x="2154613" y="1695910"/>
-            <a:ext cx="8732638" cy="1865382"/>
-          </a:xfrm>
-          <a:prstGeom prst="rect">
-            <a:avLst/>
-          </a:prstGeom>
-          <a:noFill/>
-        </p:spPr>
-        <p:txBody>
-          <a:bodyPr wrap="square">
-            <a:spAutoFit/>
-          </a:bodyPr>
-          <a:lstStyle/>
-          <a:p>
-            <a:pPr marL="1497330">
-              <a:spcBef>
-                <a:spcPts val="5"/>
-              </a:spcBef>
-            </a:pPr>
-            <a:r>
-              <a:rPr lang="en-US" sz="2400" b="1" dirty="0">
-                <a:solidFill>
-                  <a:srgbClr val="3B305B"/>
-                </a:solidFill>
-                <a:effectLst/>
-                <a:latin typeface="BC Sans"/>
-                <a:ea typeface="Verdana" panose="020B0604030504040204" pitchFamily="34" charset="0"/>
-                <a:cs typeface="Verdana" panose="020B0604030504040204" pitchFamily="34" charset="0"/>
-              </a:rPr>
-              <a:t>{{</a:t>
-            </a:r>
-            <a:r>
-              <a:rPr lang="en-US" sz="2200" b="1" dirty="0" err="1">
-                <a:solidFill>
-                  <a:srgbClr val="3B305B"/>
-                </a:solidFill>
-                <a:effectLst/>
-                <a:latin typeface="BC Sans"/>
-                <a:ea typeface="Verdana" panose="020B0604030504040204" pitchFamily="34" charset="0"/>
-                <a:cs typeface="Verdana" panose="020B0604030504040204" pitchFamily="34" charset="0"/>
-              </a:rPr>
-              <a:t>ResidenceName</a:t>
-            </a:r>
-            <a:r>
-              <a:rPr lang="en-US" sz="2400" b="1" dirty="0">
-                <a:solidFill>
-                  <a:srgbClr val="3B305B"/>
-                </a:solidFill>
-                <a:effectLst/>
-                <a:latin typeface="BC Sans"/>
-                <a:ea typeface="Verdana" panose="020B0604030504040204" pitchFamily="34" charset="0"/>
-                <a:cs typeface="Verdana" panose="020B0604030504040204" pitchFamily="34" charset="0"/>
-              </a:rPr>
-              <a:t>}}</a:t>
-            </a:r>
-          </a:p>
-          <a:p>
-            <a:pPr marL="1497330">
-              <a:spcBef>
-                <a:spcPts val="685"/>
-              </a:spcBef>
-            </a:pPr>
-            <a:r>
-              <a:rPr kumimoji="0" lang="en-US" sz="2000" b="1" i="0" u="none" strike="noStrike" kern="1200" cap="none" spc="0" normalizeH="0" baseline="0" noProof="0" dirty="0">
-                <a:ln>
-                  <a:noFill/>
-                </a:ln>
-                <a:solidFill>
-                  <a:srgbClr val="3B305B"/>
-                </a:solidFill>
-                <a:effectLst/>
-                <a:uLnTx/>
-                <a:uFillTx/>
-                <a:latin typeface="BC Sans"/>
-                <a:ea typeface="Verdana" panose="020B0604030504040204" pitchFamily="34" charset="0"/>
-                <a:cs typeface="Verdana" panose="020B0604030504040204" pitchFamily="34" charset="0"/>
-              </a:rPr>
-              <a:t>{{</a:t>
-            </a:r>
-            <a:r>
-              <a:rPr kumimoji="0" lang="en-US" sz="2000" b="1" i="0" u="none" strike="noStrike" kern="1200" cap="none" spc="0" normalizeH="0" baseline="0" noProof="0" dirty="0" err="1">
-                <a:ln>
-                  <a:noFill/>
-                </a:ln>
-                <a:solidFill>
-                  <a:srgbClr val="3B305B"/>
-                </a:solidFill>
-                <a:effectLst/>
-                <a:uLnTx/>
-                <a:uFillTx/>
-                <a:latin typeface="BC Sans"/>
-                <a:ea typeface="Verdana" panose="020B0604030504040204" pitchFamily="34" charset="0"/>
-                <a:cs typeface="Verdana" panose="020B0604030504040204" pitchFamily="34" charset="0"/>
-              </a:rPr>
-              <a:t>RegistrantName</a:t>
-            </a:r>
-            <a:r>
-              <a:rPr kumimoji="0" lang="en-US" sz="2000" b="1" i="0" u="none" strike="noStrike" kern="1200" cap="none" spc="0" normalizeH="0" baseline="0" noProof="0" dirty="0">
-                <a:ln>
-                  <a:noFill/>
-                </a:ln>
-                <a:solidFill>
-                  <a:srgbClr val="3B305B"/>
-                </a:solidFill>
-                <a:effectLst/>
-                <a:uLnTx/>
-                <a:uFillTx/>
-                <a:latin typeface="BC Sans"/>
-                <a:ea typeface="Verdana" panose="020B0604030504040204" pitchFamily="34" charset="0"/>
-                <a:cs typeface="Verdana" panose="020B0604030504040204" pitchFamily="34" charset="0"/>
-              </a:rPr>
-              <a:t>}}</a:t>
-            </a:r>
-            <a:endParaRPr lang="en-US" sz="2000" dirty="0">
-              <a:solidFill>
-                <a:srgbClr val="3B305B"/>
-              </a:solidFill>
-              <a:effectLst/>
-              <a:latin typeface="BC Sans"/>
-              <a:ea typeface="Verdana" panose="020B0604030504040204" pitchFamily="34" charset="0"/>
-              <a:cs typeface="Verdana" panose="020B0604030504040204" pitchFamily="34" charset="0"/>
-            </a:endParaRPr>
-          </a:p>
-          <a:p>
-            <a:pPr marL="1497330">
-              <a:spcBef>
-                <a:spcPts val="685"/>
-              </a:spcBef>
-              <a:spcAft>
-                <a:spcPts val="0"/>
-              </a:spcAft>
-            </a:pPr>
-            <a:r>
-              <a:rPr lang="en-US" sz="1600" dirty="0">
-                <a:solidFill>
-                  <a:srgbClr val="3B305B"/>
-                </a:solidFill>
-                <a:effectLst/>
-                <a:latin typeface="BC Sans"/>
-                <a:ea typeface="Verdana" panose="020B0604030504040204" pitchFamily="34" charset="0"/>
-                <a:cs typeface="Verdana" panose="020B0604030504040204" pitchFamily="34" charset="0"/>
-              </a:rPr>
-              <a:t>{{</a:t>
-            </a:r>
-            <a:r>
-              <a:rPr lang="en-US" sz="1600" dirty="0" err="1">
-                <a:solidFill>
-                  <a:srgbClr val="3B305B"/>
-                </a:solidFill>
-                <a:effectLst/>
-                <a:latin typeface="BC Sans"/>
-                <a:ea typeface="Verdana" panose="020B0604030504040204" pitchFamily="34" charset="0"/>
-                <a:cs typeface="Verdana" panose="020B0604030504040204" pitchFamily="34" charset="0"/>
-              </a:rPr>
-              <a:t>ResidenceAddress</a:t>
-            </a:r>
-            <a:r>
-              <a:rPr lang="en-US" sz="1600" dirty="0">
-                <a:solidFill>
-                  <a:srgbClr val="3B305B"/>
-                </a:solidFill>
-                <a:effectLst/>
-                <a:latin typeface="BC Sans"/>
-                <a:ea typeface="Verdana" panose="020B0604030504040204" pitchFamily="34" charset="0"/>
-                <a:cs typeface="Verdana" panose="020B0604030504040204" pitchFamily="34" charset="0"/>
-              </a:rPr>
-              <a:t>}}</a:t>
-            </a:r>
-          </a:p>
-          <a:p>
-            <a:pPr marL="1496060" marR="3183255">
-              <a:lnSpc>
-                <a:spcPct val="123000"/>
-              </a:lnSpc>
-              <a:spcBef>
-                <a:spcPts val="515"/>
-              </a:spcBef>
-              <a:spcAft>
-                <a:spcPts val="0"/>
-              </a:spcAft>
-            </a:pPr>
-            <a:r>
-              <a:rPr lang="en-US" sz="1400" dirty="0">
-                <a:solidFill>
-                  <a:srgbClr val="D15604"/>
-                </a:solidFill>
-                <a:effectLst/>
-                <a:latin typeface="BC Sans"/>
-                <a:ea typeface="Verdana" panose="020B0604030504040204" pitchFamily="34" charset="0"/>
-                <a:cs typeface="Verdana" panose="020B0604030504040204" pitchFamily="34" charset="0"/>
-              </a:rPr>
-              <a:t>Class: {{</a:t>
-            </a:r>
-            <a:r>
-              <a:rPr lang="en-US" sz="1400" dirty="0" err="1">
-                <a:solidFill>
-                  <a:srgbClr val="D15604"/>
-                </a:solidFill>
-                <a:effectLst/>
-                <a:latin typeface="BC Sans"/>
-                <a:ea typeface="Verdana" panose="020B0604030504040204" pitchFamily="34" charset="0"/>
-                <a:cs typeface="Verdana" panose="020B0604030504040204" pitchFamily="34" charset="0"/>
-              </a:rPr>
-              <a:t>ResidenceClassType</a:t>
-            </a:r>
-            <a:r>
-              <a:rPr lang="en-US" sz="1400" dirty="0">
-                <a:solidFill>
-                  <a:srgbClr val="D15604"/>
-                </a:solidFill>
-                <a:latin typeface="BC Sans"/>
-                <a:ea typeface="Verdana" panose="020B0604030504040204" pitchFamily="34" charset="0"/>
-                <a:cs typeface="Verdana" panose="020B0604030504040204" pitchFamily="34" charset="0"/>
-              </a:rPr>
-              <a:t>}}</a:t>
-            </a:r>
-            <a:endParaRPr lang="en-US" sz="1400" dirty="0">
-              <a:solidFill>
-                <a:srgbClr val="D15604"/>
-              </a:solidFill>
-              <a:effectLst/>
-              <a:latin typeface="BC Sans"/>
-              <a:ea typeface="Verdana" panose="020B0604030504040204" pitchFamily="34" charset="0"/>
-              <a:cs typeface="Verdana" panose="020B0604030504040204" pitchFamily="34" charset="0"/>
-            </a:endParaRPr>
-          </a:p>
-          <a:p>
-            <a:pPr marL="1496060" marR="3183255">
-              <a:lnSpc>
-                <a:spcPct val="123000"/>
-              </a:lnSpc>
-              <a:spcBef>
-                <a:spcPts val="515"/>
-              </a:spcBef>
-            </a:pPr>
-            <a:r>
-              <a:rPr lang="en-US" sz="1400" dirty="0">
-                <a:solidFill>
-                  <a:srgbClr val="3B305B"/>
-                </a:solidFill>
-                <a:effectLst/>
-                <a:latin typeface="BC Sans"/>
-                <a:ea typeface="Verdana" panose="020B0604030504040204" pitchFamily="34" charset="0"/>
-                <a:cs typeface="Verdana" panose="020B0604030504040204" pitchFamily="34" charset="0"/>
-              </a:rPr>
-              <a:t>Number</a:t>
-            </a:r>
-            <a:r>
-              <a:rPr lang="en-US" sz="1400" spc="200" dirty="0">
-                <a:solidFill>
-                  <a:srgbClr val="3B305B"/>
-                </a:solidFill>
-                <a:effectLst/>
-                <a:latin typeface="BC Sans"/>
-                <a:ea typeface="Verdana" panose="020B0604030504040204" pitchFamily="34" charset="0"/>
-                <a:cs typeface="Verdana" panose="020B0604030504040204" pitchFamily="34" charset="0"/>
-              </a:rPr>
-              <a:t> </a:t>
-            </a:r>
-            <a:r>
-              <a:rPr lang="en-US" sz="1400" dirty="0">
-                <a:solidFill>
-                  <a:srgbClr val="3B305B"/>
-                </a:solidFill>
-                <a:effectLst/>
-                <a:latin typeface="BC Sans"/>
-                <a:ea typeface="Verdana" panose="020B0604030504040204" pitchFamily="34" charset="0"/>
-                <a:cs typeface="Verdana" panose="020B0604030504040204" pitchFamily="34" charset="0"/>
-              </a:rPr>
-              <a:t>of</a:t>
-            </a:r>
-            <a:r>
-              <a:rPr lang="en-US" sz="1400" spc="200" dirty="0">
-                <a:solidFill>
-                  <a:srgbClr val="3B305B"/>
-                </a:solidFill>
-                <a:effectLst/>
-                <a:latin typeface="BC Sans"/>
-                <a:ea typeface="Verdana" panose="020B0604030504040204" pitchFamily="34" charset="0"/>
-                <a:cs typeface="Verdana" panose="020B0604030504040204" pitchFamily="34" charset="0"/>
-              </a:rPr>
-              <a:t> </a:t>
-            </a:r>
-            <a:r>
-              <a:rPr lang="en-US" sz="1400" dirty="0">
-                <a:solidFill>
-                  <a:srgbClr val="3B305B"/>
-                </a:solidFill>
-                <a:effectLst/>
-                <a:latin typeface="BC Sans"/>
-                <a:ea typeface="Verdana" panose="020B0604030504040204" pitchFamily="34" charset="0"/>
-                <a:cs typeface="Verdana" panose="020B0604030504040204" pitchFamily="34" charset="0"/>
-              </a:rPr>
-              <a:t>units: {{</a:t>
-            </a:r>
-            <a:r>
-              <a:rPr lang="en-US" sz="1400" dirty="0" err="1">
-                <a:solidFill>
-                  <a:srgbClr val="3B305B"/>
-                </a:solidFill>
-                <a:effectLst/>
-                <a:latin typeface="BC Sans"/>
-                <a:ea typeface="Verdana" panose="020B0604030504040204" pitchFamily="34" charset="0"/>
-                <a:cs typeface="Verdana" panose="020B0604030504040204" pitchFamily="34" charset="0"/>
-              </a:rPr>
-              <a:t>TotalUnits</a:t>
-            </a:r>
-            <a:r>
-              <a:rPr lang="en-US" sz="1400" dirty="0">
-                <a:solidFill>
-                  <a:srgbClr val="3B305B"/>
-                </a:solidFill>
-                <a:effectLst/>
-                <a:latin typeface="BC Sans"/>
-                <a:ea typeface="Verdana" panose="020B0604030504040204" pitchFamily="34" charset="0"/>
-                <a:cs typeface="Verdana" panose="020B0604030504040204" pitchFamily="34" charset="0"/>
-              </a:rPr>
-              <a:t>}}</a:t>
-            </a:r>
-          </a:p>
-        </p:txBody>
-      </p:sp>
-      <p:sp>
-        <p:nvSpPr>
-          <p:cNvPr id="10" name="TextBox 9">
-            <a:extLst>
-              <a:ext uri="{FF2B5EF4-FFF2-40B4-BE49-F238E27FC236}">
-                <a16:creationId xmlns:a16="http://schemas.microsoft.com/office/drawing/2014/main" id="{F5EFC51F-4E8E-3399-8BFC-6415F21F1C0F}"/>
-              </a:ext>
-            </a:extLst>
-          </p:cNvPr>
-          <p:cNvSpPr txBox="1"/>
-          <p:nvPr/>
-        </p:nvSpPr>
-        <p:spPr>
-          <a:xfrm>
-            <a:off x="1684421" y="676025"/>
-            <a:ext cx="8469856" cy="430887"/>
-          </a:xfrm>
-          <a:prstGeom prst="rect">
-            <a:avLst/>
-          </a:prstGeom>
-          <a:noFill/>
-        </p:spPr>
-        <p:txBody>
-          <a:bodyPr wrap="square">
-            <a:spAutoFit/>
-          </a:bodyPr>
-          <a:lstStyle/>
-          <a:p>
-            <a:pPr marL="1497330">
-              <a:spcBef>
-                <a:spcPts val="5"/>
-              </a:spcBef>
-            </a:pPr>
-            <a:r>
-              <a:rPr lang="en-US" sz="2200" b="1" dirty="0">
-                <a:solidFill>
-                  <a:srgbClr val="3B305B"/>
-                </a:solidFill>
-                <a:effectLst/>
-                <a:latin typeface="BC Sans"/>
-                <a:ea typeface="Verdana" panose="020B0604030504040204" pitchFamily="34" charset="0"/>
-                <a:cs typeface="Verdana" panose="020B0604030504040204" pitchFamily="34" charset="0"/>
-              </a:rPr>
-              <a:t>Ministry of Health, Assisted Living Registry</a:t>
-            </a:r>
           </a:p>
         </p:txBody>
       </p:sp>
@@ -4091,7 +3678,7 @@
                 <a:ea typeface="Verdana" panose="020B0604030504040204" pitchFamily="34" charset="0"/>
                 <a:cs typeface="Verdana" panose="020B0604030504040204" pitchFamily="34" charset="0"/>
               </a:rPr>
-              <a:t>   {{</a:t>
+              <a:t>  {{</a:t>
             </a:r>
             <a:r>
               <a:rPr lang="en-US" sz="1400" b="1" dirty="0" err="1">
@@ -4203,7 +3790,7 @@
         <p:spPr>
           <a:xfrm>
             <a:off x="3426793" y="6427723"/>
-            <a:ext cx="2228049" cy="523220"/>
+            <a:ext cx="2442411" cy="523220"/>
           </a:xfrm>
           <a:prstGeom prst="rect">
             <a:avLst/>
@@ -4302,10 +3889,10 @@
       </p:pic>
       <p:sp>
         <p:nvSpPr>
-          <p:cNvPr id="17" name="TextBox 8">
+          <p:cNvPr id="4" name="TextBox 3">
             <a:extLst>
               <a:ext uri="{FF2B5EF4-FFF2-40B4-BE49-F238E27FC236}">
-                <a16:creationId xmlns:a16="http://schemas.microsoft.com/office/drawing/2014/main" id="{2661C2CE-7AAD-2E59-A527-EDBEF23061BD}"/>
+                <a16:creationId xmlns:a16="http://schemas.microsoft.com/office/drawing/2014/main" id="{D0D2C10B-AE2F-04B3-E4B9-525B4034F427}"/>
               </a:ext>
             </a:extLst>
           </p:cNvPr>
@@ -4314,8 +3901,8 @@
         </p:nvSpPr>
         <p:spPr>
           <a:xfrm>
-            <a:off x="2144105" y="3722905"/>
-            <a:ext cx="10993954" cy="1212320"/>
+            <a:off x="3580648" y="1559197"/>
+            <a:ext cx="6178979" cy="2670411"/>
           </a:xfrm>
           <a:prstGeom prst="rect">
             <a:avLst/>
@@ -4326,109 +3913,233 @@
           <a:bodyPr wrap="square">
             <a:spAutoFit/>
           </a:bodyPr>
-          <a:lstStyle>
-            <a:defPPr>
-              <a:defRPr lang="en-US"/>
-            </a:defPPr>
-            <a:lvl1pPr marL="0" algn="l" defTabSz="457200" rtl="0" eaLnBrk="1" latinLnBrk="0" hangingPunct="1">
-              <a:defRPr sz="1800" kern="1200">
-                <a:solidFill>
-                  <a:schemeClr val="tx1"/>
-                </a:solidFill>
-                <a:latin typeface="+mn-lt"/>
-                <a:ea typeface="+mn-ea"/>
-                <a:cs typeface="+mn-cs"/>
-              </a:defRPr>
-            </a:lvl1pPr>
-            <a:lvl2pPr marL="457200" algn="l" defTabSz="457200" rtl="0" eaLnBrk="1" latinLnBrk="0" hangingPunct="1">
-              <a:defRPr sz="1800" kern="1200">
-                <a:solidFill>
-                  <a:schemeClr val="tx1"/>
-                </a:solidFill>
-                <a:latin typeface="+mn-lt"/>
-                <a:ea typeface="+mn-ea"/>
-                <a:cs typeface="+mn-cs"/>
-              </a:defRPr>
-            </a:lvl2pPr>
-            <a:lvl3pPr marL="914400" algn="l" defTabSz="457200" rtl="0" eaLnBrk="1" latinLnBrk="0" hangingPunct="1">
-              <a:defRPr sz="1800" kern="1200">
-                <a:solidFill>
-                  <a:schemeClr val="tx1"/>
-                </a:solidFill>
-                <a:latin typeface="+mn-lt"/>
-                <a:ea typeface="+mn-ea"/>
-                <a:cs typeface="+mn-cs"/>
-              </a:defRPr>
-            </a:lvl3pPr>
-            <a:lvl4pPr marL="1371600" algn="l" defTabSz="457200" rtl="0" eaLnBrk="1" latinLnBrk="0" hangingPunct="1">
-              <a:defRPr sz="1800" kern="1200">
-                <a:solidFill>
-                  <a:schemeClr val="tx1"/>
-                </a:solidFill>
-                <a:latin typeface="+mn-lt"/>
-                <a:ea typeface="+mn-ea"/>
-                <a:cs typeface="+mn-cs"/>
-              </a:defRPr>
-            </a:lvl4pPr>
-            <a:lvl5pPr marL="1828800" algn="l" defTabSz="457200" rtl="0" eaLnBrk="1" latinLnBrk="0" hangingPunct="1">
-              <a:defRPr sz="1800" kern="1200">
-                <a:solidFill>
-                  <a:schemeClr val="tx1"/>
-                </a:solidFill>
-                <a:latin typeface="+mn-lt"/>
-                <a:ea typeface="+mn-ea"/>
-                <a:cs typeface="+mn-cs"/>
-              </a:defRPr>
-            </a:lvl5pPr>
-            <a:lvl6pPr marL="2286000" algn="l" defTabSz="457200" rtl="0" eaLnBrk="1" latinLnBrk="0" hangingPunct="1">
-              <a:defRPr sz="1800" kern="1200">
-                <a:solidFill>
-                  <a:schemeClr val="tx1"/>
-                </a:solidFill>
-                <a:latin typeface="+mn-lt"/>
-                <a:ea typeface="+mn-ea"/>
-                <a:cs typeface="+mn-cs"/>
-              </a:defRPr>
-            </a:lvl6pPr>
-            <a:lvl7pPr marL="2743200" algn="l" defTabSz="457200" rtl="0" eaLnBrk="1" latinLnBrk="0" hangingPunct="1">
-              <a:defRPr sz="1800" kern="1200">
-                <a:solidFill>
-                  <a:schemeClr val="tx1"/>
-                </a:solidFill>
-                <a:latin typeface="+mn-lt"/>
-                <a:ea typeface="+mn-ea"/>
-                <a:cs typeface="+mn-cs"/>
-              </a:defRPr>
-            </a:lvl7pPr>
-            <a:lvl8pPr marL="3200400" algn="l" defTabSz="457200" rtl="0" eaLnBrk="1" latinLnBrk="0" hangingPunct="1">
-              <a:defRPr sz="1800" kern="1200">
-                <a:solidFill>
-                  <a:schemeClr val="tx1"/>
-                </a:solidFill>
-                <a:latin typeface="+mn-lt"/>
-                <a:ea typeface="+mn-ea"/>
-                <a:cs typeface="+mn-cs"/>
-              </a:defRPr>
-            </a:lvl8pPr>
-            <a:lvl9pPr marL="3657600" algn="l" defTabSz="457200" rtl="0" eaLnBrk="1" latinLnBrk="0" hangingPunct="1">
-              <a:defRPr sz="1800" kern="1200">
-                <a:solidFill>
-                  <a:schemeClr val="tx1"/>
-                </a:solidFill>
-                <a:latin typeface="+mn-lt"/>
-                <a:ea typeface="+mn-ea"/>
-                <a:cs typeface="+mn-cs"/>
-              </a:defRPr>
-            </a:lvl9pPr>
-          </a:lstStyle>
-          <a:p>
-            <a:pPr marL="1496060" marR="3183255">
+          <a:lstStyle/>
+          <a:p>
+            <a:pPr>
               <a:lnSpc>
-                <a:spcPct val="123000"/>
+                <a:spcPct val="110000"/>
+              </a:lnSpc>
+              <a:spcAft>
+                <a:spcPts val="300"/>
+              </a:spcAft>
+            </a:pPr>
+            <a:r>
+              <a:rPr lang="en-US" sz="2200" b="1" dirty="0">
+                <a:solidFill>
+                  <a:srgbClr val="3B305B"/>
+                </a:solidFill>
+                <a:latin typeface="BC Sans"/>
+                <a:ea typeface="Verdana" panose="020B0604030504040204" pitchFamily="34" charset="0"/>
+                <a:cs typeface="Verdana" panose="020B0604030504040204" pitchFamily="34" charset="0"/>
+              </a:rPr>
+              <a:t>{{</a:t>
+            </a:r>
+            <a:r>
+              <a:rPr lang="en-US" sz="2200" b="1" dirty="0" err="1">
+                <a:solidFill>
+                  <a:srgbClr val="3B305B"/>
+                </a:solidFill>
+                <a:latin typeface="BC Sans"/>
+                <a:ea typeface="Verdana" panose="020B0604030504040204" pitchFamily="34" charset="0"/>
+                <a:cs typeface="Verdana" panose="020B0604030504040204" pitchFamily="34" charset="0"/>
+              </a:rPr>
+              <a:t>ResidenceName</a:t>
+            </a:r>
+            <a:r>
+              <a:rPr lang="en-US" sz="2200" b="1" dirty="0">
+                <a:solidFill>
+                  <a:srgbClr val="3B305B"/>
+                </a:solidFill>
+                <a:latin typeface="BC Sans"/>
+                <a:ea typeface="Verdana" panose="020B0604030504040204" pitchFamily="34" charset="0"/>
+                <a:cs typeface="Verdana" panose="020B0604030504040204" pitchFamily="34" charset="0"/>
+              </a:rPr>
+              <a:t>}}</a:t>
+            </a:r>
+          </a:p>
+          <a:p>
+            <a:pPr>
+              <a:lnSpc>
+                <a:spcPct val="110000"/>
+              </a:lnSpc>
+              <a:spcAft>
+                <a:spcPts val="300"/>
+              </a:spcAft>
+            </a:pPr>
+            <a:r>
+              <a:rPr lang="en-US" sz="2000" b="1" dirty="0">
+                <a:solidFill>
+                  <a:srgbClr val="3B305B"/>
+                </a:solidFill>
+                <a:latin typeface="BC Sans"/>
+                <a:ea typeface="Verdana" panose="020B0604030504040204" pitchFamily="34" charset="0"/>
+                <a:cs typeface="Verdana" panose="020B0604030504040204" pitchFamily="34" charset="0"/>
+              </a:rPr>
+              <a:t>{{</a:t>
+            </a:r>
+            <a:r>
+              <a:rPr lang="en-US" sz="2000" b="1" dirty="0" err="1">
+                <a:solidFill>
+                  <a:srgbClr val="3B305B"/>
+                </a:solidFill>
+                <a:latin typeface="BC Sans"/>
+                <a:ea typeface="Verdana" panose="020B0604030504040204" pitchFamily="34" charset="0"/>
+                <a:cs typeface="Verdana" panose="020B0604030504040204" pitchFamily="34" charset="0"/>
+              </a:rPr>
+              <a:t>RegistrantName</a:t>
+            </a:r>
+            <a:r>
+              <a:rPr lang="en-US" sz="2000" b="1" dirty="0">
+                <a:solidFill>
+                  <a:srgbClr val="3B305B"/>
+                </a:solidFill>
+                <a:latin typeface="BC Sans"/>
+                <a:ea typeface="Verdana" panose="020B0604030504040204" pitchFamily="34" charset="0"/>
+                <a:cs typeface="Verdana" panose="020B0604030504040204" pitchFamily="34" charset="0"/>
+              </a:rPr>
+              <a:t>}}</a:t>
+            </a:r>
+          </a:p>
+          <a:p>
+            <a:pPr>
+              <a:lnSpc>
+                <a:spcPct val="110000"/>
+              </a:lnSpc>
+              <a:spcAft>
+                <a:spcPts val="300"/>
+              </a:spcAft>
+            </a:pPr>
+            <a:r>
+              <a:rPr lang="en-US" sz="1600" dirty="0">
+                <a:solidFill>
+                  <a:srgbClr val="3B305B"/>
+                </a:solidFill>
+                <a:latin typeface="BC Sans"/>
+                <a:ea typeface="Verdana" panose="020B0604030504040204" pitchFamily="34" charset="0"/>
+                <a:cs typeface="Verdana" panose="020B0604030504040204" pitchFamily="34" charset="0"/>
+              </a:rPr>
+              <a:t>{{</a:t>
+            </a:r>
+            <a:r>
+              <a:rPr lang="en-US" sz="1600" dirty="0" err="1">
+                <a:solidFill>
+                  <a:srgbClr val="3B305B"/>
+                </a:solidFill>
+                <a:latin typeface="BC Sans"/>
+                <a:ea typeface="Verdana" panose="020B0604030504040204" pitchFamily="34" charset="0"/>
+                <a:cs typeface="Verdana" panose="020B0604030504040204" pitchFamily="34" charset="0"/>
+              </a:rPr>
+              <a:t>ResidenceAddress</a:t>
+            </a:r>
+            <a:r>
+              <a:rPr lang="en-US" sz="1600" dirty="0">
+                <a:solidFill>
+                  <a:srgbClr val="3B305B"/>
+                </a:solidFill>
+                <a:latin typeface="BC Sans"/>
+                <a:ea typeface="Verdana" panose="020B0604030504040204" pitchFamily="34" charset="0"/>
+                <a:cs typeface="Verdana" panose="020B0604030504040204" pitchFamily="34" charset="0"/>
+              </a:rPr>
+              <a:t>}}</a:t>
+            </a:r>
+          </a:p>
+          <a:p>
+            <a:pPr>
+              <a:lnSpc>
+                <a:spcPct val="110000"/>
+              </a:lnSpc>
+              <a:spcAft>
+                <a:spcPts val="300"/>
+              </a:spcAft>
+            </a:pPr>
+            <a:r>
+              <a:rPr lang="en-US" sz="1400" dirty="0">
+                <a:solidFill>
+                  <a:schemeClr val="accent2"/>
+                </a:solidFill>
+                <a:latin typeface="BC Sans"/>
+                <a:ea typeface="Verdana" panose="020B0604030504040204" pitchFamily="34" charset="0"/>
+                <a:cs typeface="Verdana" panose="020B0604030504040204" pitchFamily="34" charset="0"/>
+              </a:rPr>
+              <a:t>Class: {{</a:t>
+            </a:r>
+            <a:r>
+              <a:rPr lang="en-US" sz="1400" dirty="0" err="1">
+                <a:solidFill>
+                  <a:schemeClr val="accent2"/>
+                </a:solidFill>
+                <a:latin typeface="BC Sans"/>
+                <a:ea typeface="Verdana" panose="020B0604030504040204" pitchFamily="34" charset="0"/>
+                <a:cs typeface="Verdana" panose="020B0604030504040204" pitchFamily="34" charset="0"/>
+              </a:rPr>
+              <a:t>ResidenceClassType</a:t>
+            </a:r>
+            <a:r>
+              <a:rPr lang="en-US" sz="1400" dirty="0">
+                <a:solidFill>
+                  <a:schemeClr val="accent2"/>
+                </a:solidFill>
+                <a:latin typeface="BC Sans"/>
+                <a:ea typeface="Verdana" panose="020B0604030504040204" pitchFamily="34" charset="0"/>
+                <a:cs typeface="Verdana" panose="020B0604030504040204" pitchFamily="34" charset="0"/>
+              </a:rPr>
+              <a:t>}}</a:t>
+            </a:r>
+          </a:p>
+          <a:p>
+            <a:pPr>
+              <a:lnSpc>
+                <a:spcPct val="110000"/>
+              </a:lnSpc>
+              <a:spcAft>
+                <a:spcPts val="300"/>
+              </a:spcAft>
+            </a:pPr>
+            <a:r>
+              <a:rPr lang="en-US" sz="1400" dirty="0">
+                <a:solidFill>
+                  <a:srgbClr val="3B305B"/>
+                </a:solidFill>
+                <a:latin typeface="BC Sans"/>
+                <a:ea typeface="Verdana" panose="020B0604030504040204" pitchFamily="34" charset="0"/>
+                <a:cs typeface="Verdana" panose="020B0604030504040204" pitchFamily="34" charset="0"/>
+              </a:rPr>
+              <a:t>Number of units: {{</a:t>
+            </a:r>
+            <a:r>
+              <a:rPr lang="en-US" sz="1400" dirty="0" err="1">
+                <a:solidFill>
+                  <a:srgbClr val="3B305B"/>
+                </a:solidFill>
+                <a:latin typeface="BC Sans"/>
+                <a:ea typeface="Verdana" panose="020B0604030504040204" pitchFamily="34" charset="0"/>
+                <a:cs typeface="Verdana" panose="020B0604030504040204" pitchFamily="34" charset="0"/>
+              </a:rPr>
+              <a:t>TotalUnits</a:t>
+            </a:r>
+            <a:r>
+              <a:rPr lang="en-US" sz="1400" dirty="0">
+                <a:solidFill>
+                  <a:srgbClr val="3B305B"/>
+                </a:solidFill>
+                <a:latin typeface="BC Sans"/>
+                <a:ea typeface="Verdana" panose="020B0604030504040204" pitchFamily="34" charset="0"/>
+                <a:cs typeface="Verdana" panose="020B0604030504040204" pitchFamily="34" charset="0"/>
+              </a:rPr>
+              <a:t>}}</a:t>
+            </a:r>
+          </a:p>
+          <a:p>
+            <a:pPr>
+              <a:lnSpc>
+                <a:spcPct val="110000"/>
               </a:lnSpc>
               <a:spcBef>
-                <a:spcPts val="515"/>
+                <a:spcPts val="600"/>
               </a:spcBef>
+              <a:spcAft>
+                <a:spcPts val="300"/>
+              </a:spcAft>
             </a:pPr>
             <a:r>
               <a:rPr lang="en-US" sz="1400" dirty="0">
@@ -4441,11 +4152,10 @@
               <a:t>Assisted Living Service(s): {{</a:t>
             </a:r>
             <a:r>
-              <a:rPr lang="en-US" sz="1400" b="0" dirty="0">
+              <a:rPr lang="en-US" sz="1400" dirty="0">
                 <a:solidFill>
                   <a:srgbClr val="A31515"/>
                 </a:solidFill>
-                <a:effectLst/>
                 <a:latin typeface="Consolas" panose="020B0609020204030204" pitchFamily="49" charset="0"/>
               </a:rPr>
               <a:t>Services</a:t>
@@ -4462,87 +4172,119 @@
             </a:r>
           </a:p>
           <a:p>
-            <a:pPr marL="1496060" marR="3183255">
+            <a:pPr>
               <a:lnSpc>
-                <a:spcPct val="123000"/>
+                <a:spcPct val="110000"/>
               </a:lnSpc>
               <a:spcBef>
-                <a:spcPts val="515"/>
+                <a:spcPts val="600"/>
+              </a:spcBef>
+              <a:spcAft>
+                <a:spcPts val="300"/>
+              </a:spcAft>
+            </a:pPr>
+            <a:r>
+              <a:rPr lang="en-US" sz="1400" b="1" dirty="0">
+                <a:solidFill>
+                  <a:srgbClr val="3B305B"/>
+                </a:solidFill>
+                <a:latin typeface="BC Sans"/>
+                <a:ea typeface="Verdana" panose="020B0604030504040204" pitchFamily="34" charset="0"/>
+                <a:cs typeface="Verdana" panose="020B0604030504040204" pitchFamily="34" charset="0"/>
+              </a:rPr>
+              <a:t>CONDITIONS:</a:t>
+            </a:r>
+          </a:p>
+          <a:p>
+            <a:pPr>
+              <a:lnSpc>
+                <a:spcPct val="110000"/>
+              </a:lnSpc>
+              <a:spcAft>
+                <a:spcPts val="300"/>
+              </a:spcAft>
+            </a:pPr>
+            <a:r>
+              <a:rPr lang="en-US" sz="1400" dirty="0">
+                <a:solidFill>
+                  <a:srgbClr val="3B305B"/>
+                </a:solidFill>
+                <a:latin typeface="BC Sans"/>
+                <a:ea typeface="Verdana" panose="020B0604030504040204" pitchFamily="34" charset="0"/>
+                <a:cs typeface="Verdana" panose="020B0604030504040204" pitchFamily="34" charset="0"/>
+              </a:rPr>
+              <a:t>{{</a:t>
+            </a:r>
+            <a:r>
+              <a:rPr lang="en-US" sz="1400" dirty="0" err="1">
+                <a:solidFill>
+                  <a:srgbClr val="3B305B"/>
+                </a:solidFill>
+                <a:latin typeface="BC Sans"/>
+                <a:ea typeface="Verdana" panose="020B0604030504040204" pitchFamily="34" charset="0"/>
+                <a:cs typeface="Verdana" panose="020B0604030504040204" pitchFamily="34" charset="0"/>
+              </a:rPr>
+              <a:t>ConditionAndDescription</a:t>
+            </a:r>
+            <a:r>
+              <a:rPr lang="en-US" sz="1400" dirty="0">
+                <a:solidFill>
+                  <a:srgbClr val="3B305B"/>
+                </a:solidFill>
+                <a:latin typeface="BC Sans"/>
+                <a:ea typeface="Verdana" panose="020B0604030504040204" pitchFamily="34" charset="0"/>
+                <a:cs typeface="Verdana" panose="020B0604030504040204" pitchFamily="34" charset="0"/>
+              </a:rPr>
+              <a:t>}} {{ConditionAndDescription1}}</a:t>
+            </a:r>
+          </a:p>
+        </p:txBody>
+      </p:sp>
+      <p:sp>
+        <p:nvSpPr>
+          <p:cNvPr id="18" name="TextBox 17">
+            <a:extLst>
+              <a:ext uri="{FF2B5EF4-FFF2-40B4-BE49-F238E27FC236}">
+                <a16:creationId xmlns:a16="http://schemas.microsoft.com/office/drawing/2014/main" id="{459CC68B-34B1-EB7A-33EE-937880F7934D}"/>
+              </a:ext>
+            </a:extLst>
+          </p:cNvPr>
+          <p:cNvSpPr txBox="1"/>
+          <p:nvPr/>
+        </p:nvSpPr>
+        <p:spPr>
+          <a:xfrm>
+            <a:off x="1688558" y="619732"/>
+            <a:ext cx="8469856" cy="430887"/>
+          </a:xfrm>
+          <a:prstGeom prst="rect">
+            <a:avLst/>
+          </a:prstGeom>
+          <a:noFill/>
+        </p:spPr>
+        <p:txBody>
+          <a:bodyPr wrap="square">
+            <a:spAutoFit/>
+          </a:bodyPr>
+          <a:lstStyle/>
+          <a:p>
+            <a:pPr marL="1497330">
+              <a:spcBef>
+                <a:spcPts val="5"/>
               </a:spcBef>
             </a:pPr>
-            <a:endParaRPr lang="en-US" sz="800" dirty="0">
-              <a:solidFill>
-                <a:srgbClr val="3B305B"/>
-              </a:solidFill>
-              <a:latin typeface="BC Sans"/>
-              <a:ea typeface="Verdana" panose="020B0604030504040204" pitchFamily="34" charset="0"/>
-            </a:endParaRPr>
-          </a:p>
-          <a:p>
-            <a:pPr marL="1496060" marR="3183255">
-              <a:lnSpc>
-                <a:spcPct val="123000"/>
-              </a:lnSpc>
-              <a:spcBef>
-                <a:spcPts val="515"/>
-              </a:spcBef>
-            </a:pPr>
-            <a:r>
-              <a:rPr lang="en-US" sz="1400" b="1" dirty="0">
+            <a:r>
+              <a:rPr lang="en-US" sz="2200" b="1" dirty="0">
                 <a:solidFill>
                   <a:srgbClr val="3B305B"/>
                 </a:solidFill>
+                <a:effectLst/>
                 <a:latin typeface="BC Sans"/>
                 <a:ea typeface="Verdana" panose="020B0604030504040204" pitchFamily="34" charset="0"/>
+                <a:cs typeface="Verdana" panose="020B0604030504040204" pitchFamily="34" charset="0"/>
               </a:rPr>
-              <a:t>CONDITIONS:</a:t>
-            </a:r>
-          </a:p>
-          <a:p>
-            <a:pPr marL="1496060" marR="3183255">
-              <a:lnSpc>
-                <a:spcPct val="123000"/>
-              </a:lnSpc>
-              <a:spcBef>
-                <a:spcPts val="515"/>
-              </a:spcBef>
-            </a:pPr>
-            <a:r>
-              <a:rPr lang="en-US" sz="1400" dirty="0">
-                <a:solidFill>
-                  <a:srgbClr val="3B305B"/>
-                </a:solidFill>
-                <a:latin typeface="BC Sans"/>
-                <a:ea typeface="Verdana" panose="020B0604030504040204" pitchFamily="34" charset="0"/>
-              </a:rPr>
-              <a:t>{{</a:t>
-            </a:r>
-            <a:r>
-              <a:rPr lang="en-US" sz="1400" dirty="0" err="1">
-                <a:solidFill>
-                  <a:srgbClr val="3B305B"/>
-                </a:solidFill>
-                <a:latin typeface="BC Sans"/>
-                <a:ea typeface="Verdana" panose="020B0604030504040204" pitchFamily="34" charset="0"/>
-              </a:rPr>
-              <a:t>ConditionAndDescription</a:t>
-            </a:r>
-            <a:r>
-              <a:rPr lang="en-US" sz="1400" dirty="0">
-                <a:solidFill>
-                  <a:srgbClr val="3B305B"/>
-                </a:solidFill>
-                <a:latin typeface="BC Sans"/>
-                <a:ea typeface="Verdana" panose="020B0604030504040204" pitchFamily="34" charset="0"/>
-              </a:rPr>
-              <a:t>}} {{ConditionAndDescription1}}</a:t>
-            </a:r>
-            <a:endParaRPr lang="en-CA" sz="800" dirty="0">
-              <a:effectLst/>
-              <a:latin typeface="BC Sans"/>
-              <a:ea typeface="Verdana" panose="020B0604030504040204" pitchFamily="34" charset="0"/>
-              <a:cs typeface="Verdana" panose="020B0604030504040204" pitchFamily="34" charset="0"/>
-            </a:endParaRPr>
+              <a:t>Ministry of Health, Assisted Living Registry</a:t>
+            </a:r>
           </a:p>
         </p:txBody>
       </p:sp>

</xml_diff>

<commit_message>
Updated the certificates as per ALR team Req
</commit_message>
<xml_diff>
--- a/ALR-DocgenTemplates/CertificateBackground_MH.pptx
+++ b/ALR-DocgenTemplates/CertificateBackground_MH.pptx
@@ -243,7 +243,7 @@
           <a:p>
             <a:fld id="{E0C45857-5204-4055-BBBB-5D81F6C0DEE1}" type="datetimeFigureOut">
               <a:rPr lang="en-US" smtClean="0"/>
-              <a:t>4/30/2026</a:t>
+              <a:t>7/29/2026</a:t>
             </a:fld>
             <a:endParaRPr lang="en-US"/>
           </a:p>
@@ -413,7 +413,7 @@
           <a:p>
             <a:fld id="{E0C45857-5204-4055-BBBB-5D81F6C0DEE1}" type="datetimeFigureOut">
               <a:rPr lang="en-US" smtClean="0"/>
-              <a:t>4/30/2026</a:t>
+              <a:t>7/29/2026</a:t>
             </a:fld>
             <a:endParaRPr lang="en-US"/>
           </a:p>
@@ -593,7 +593,7 @@
           <a:p>
             <a:fld id="{E0C45857-5204-4055-BBBB-5D81F6C0DEE1}" type="datetimeFigureOut">
               <a:rPr lang="en-US" smtClean="0"/>
-              <a:t>4/30/2026</a:t>
+              <a:t>7/29/2026</a:t>
             </a:fld>
             <a:endParaRPr lang="en-US"/>
           </a:p>
@@ -763,7 +763,7 @@
           <a:p>
             <a:fld id="{E0C45857-5204-4055-BBBB-5D81F6C0DEE1}" type="datetimeFigureOut">
               <a:rPr lang="en-US" smtClean="0"/>
-              <a:t>4/30/2026</a:t>
+              <a:t>7/29/2026</a:t>
             </a:fld>
             <a:endParaRPr lang="en-US"/>
           </a:p>
@@ -1007,7 +1007,7 @@
           <a:p>
             <a:fld id="{E0C45857-5204-4055-BBBB-5D81F6C0DEE1}" type="datetimeFigureOut">
               <a:rPr lang="en-US" smtClean="0"/>
-              <a:t>4/30/2026</a:t>
+              <a:t>7/29/2026</a:t>
             </a:fld>
             <a:endParaRPr lang="en-US"/>
           </a:p>
@@ -1239,7 +1239,7 @@
           <a:p>
             <a:fld id="{E0C45857-5204-4055-BBBB-5D81F6C0DEE1}" type="datetimeFigureOut">
               <a:rPr lang="en-US" smtClean="0"/>
-              <a:t>4/30/2026</a:t>
+              <a:t>7/29/2026</a:t>
             </a:fld>
             <a:endParaRPr lang="en-US"/>
           </a:p>
@@ -1606,7 +1606,7 @@
           <a:p>
             <a:fld id="{E0C45857-5204-4055-BBBB-5D81F6C0DEE1}" type="datetimeFigureOut">
               <a:rPr lang="en-US" smtClean="0"/>
-              <a:t>4/30/2026</a:t>
+              <a:t>7/29/2026</a:t>
             </a:fld>
             <a:endParaRPr lang="en-US"/>
           </a:p>
@@ -1724,7 +1724,7 @@
           <a:p>
             <a:fld id="{E0C45857-5204-4055-BBBB-5D81F6C0DEE1}" type="datetimeFigureOut">
               <a:rPr lang="en-US" smtClean="0"/>
-              <a:t>4/30/2026</a:t>
+              <a:t>7/29/2026</a:t>
             </a:fld>
             <a:endParaRPr lang="en-US"/>
           </a:p>
@@ -1819,7 +1819,7 @@
           <a:p>
             <a:fld id="{E0C45857-5204-4055-BBBB-5D81F6C0DEE1}" type="datetimeFigureOut">
               <a:rPr lang="en-US" smtClean="0"/>
-              <a:t>4/30/2026</a:t>
+              <a:t>7/29/2026</a:t>
             </a:fld>
             <a:endParaRPr lang="en-US"/>
           </a:p>
@@ -2096,7 +2096,7 @@
           <a:p>
             <a:fld id="{E0C45857-5204-4055-BBBB-5D81F6C0DEE1}" type="datetimeFigureOut">
               <a:rPr lang="en-US" smtClean="0"/>
-              <a:t>4/30/2026</a:t>
+              <a:t>7/29/2026</a:t>
             </a:fld>
             <a:endParaRPr lang="en-US"/>
           </a:p>
@@ -2353,7 +2353,7 @@
           <a:p>
             <a:fld id="{E0C45857-5204-4055-BBBB-5D81F6C0DEE1}" type="datetimeFigureOut">
               <a:rPr lang="en-US" smtClean="0"/>
-              <a:t>4/30/2026</a:t>
+              <a:t>7/29/2026</a:t>
             </a:fld>
             <a:endParaRPr lang="en-US"/>
           </a:p>
@@ -2566,7 +2566,7 @@
           <a:p>
             <a:fld id="{E0C45857-5204-4055-BBBB-5D81F6C0DEE1}" type="datetimeFigureOut">
               <a:rPr lang="en-US" smtClean="0"/>
-              <a:t>4/30/2026</a:t>
+              <a:t>7/29/2026</a:t>
             </a:fld>
             <a:endParaRPr lang="en-US"/>
           </a:p>
@@ -3047,7 +3047,7 @@
         </p:blipFill>
         <p:spPr bwMode="auto">
           <a:xfrm>
-            <a:off x="-57248" y="-17293"/>
+            <a:off x="-33338" y="-12007"/>
             <a:ext cx="10125076" cy="7784407"/>
           </a:xfrm>
           <a:prstGeom prst="rect">
@@ -3572,8 +3572,8 @@
         </p:nvCxnSpPr>
         <p:spPr>
           <a:xfrm>
-            <a:off x="3247696" y="1291080"/>
-            <a:ext cx="6035961" cy="0"/>
+            <a:off x="3096000" y="910800"/>
+            <a:ext cx="6162086" cy="0"/>
           </a:xfrm>
           <a:prstGeom prst="line">
             <a:avLst/>
@@ -3678,7 +3678,7 @@
                 <a:ea typeface="Verdana" panose="020B0604030504040204" pitchFamily="34" charset="0"/>
                 <a:cs typeface="Verdana" panose="020B0604030504040204" pitchFamily="34" charset="0"/>
               </a:rPr>
-              <a:t>  {{</a:t>
+              <a:t>   {{</a:t>
             </a:r>
             <a:r>
               <a:rPr lang="en-US" sz="1400" b="1" dirty="0" err="1">
@@ -3790,7 +3790,7 @@
         <p:spPr>
           <a:xfrm>
             <a:off x="3426793" y="6427723"/>
-            <a:ext cx="2442411" cy="523220"/>
+            <a:ext cx="2228049" cy="523220"/>
           </a:xfrm>
           <a:prstGeom prst="rect">
             <a:avLst/>
@@ -3875,8 +3875,8 @@
         </p:blipFill>
         <p:spPr>
           <a:xfrm>
-            <a:off x="2207164" y="1681641"/>
-            <a:ext cx="1181100" cy="1181100"/>
+            <a:off x="1808911" y="1583963"/>
+            <a:ext cx="1049498" cy="1049498"/>
           </a:xfrm>
           <a:prstGeom prst="rect">
             <a:avLst/>
@@ -3901,8 +3901,8 @@
         </p:nvSpPr>
         <p:spPr>
           <a:xfrm>
-            <a:off x="3580648" y="1559197"/>
-            <a:ext cx="6178979" cy="2670411"/>
+            <a:off x="3029049" y="1123592"/>
+            <a:ext cx="6177600" cy="3560400"/>
           </a:xfrm>
           <a:prstGeom prst="rect">
             <a:avLst/>
@@ -3914,6 +3914,92 @@
             <a:spAutoFit/>
           </a:bodyPr>
           <a:lstStyle/>
+          <a:p>
+            <a:pPr>
+              <a:lnSpc>
+                <a:spcPct val="200000"/>
+              </a:lnSpc>
+              <a:spcAft>
+                <a:spcPts val="300"/>
+              </a:spcAft>
+            </a:pPr>
+            <a:r>
+              <a:rPr lang="en-US" b="1" dirty="0">
+                <a:solidFill>
+                  <a:srgbClr val="3B305B"/>
+                </a:solidFill>
+                <a:latin typeface="BC Sans"/>
+                <a:ea typeface="Verdana" panose="020B0604030504040204" pitchFamily="34" charset="0"/>
+                <a:cs typeface="Verdana" panose="020B0604030504040204" pitchFamily="34" charset="0"/>
+              </a:rPr>
+              <a:t>{{</a:t>
+            </a:r>
+            <a:r>
+              <a:rPr lang="en-US" sz="1900" b="1" dirty="0" err="1">
+                <a:solidFill>
+                  <a:srgbClr val="3B305B"/>
+                </a:solidFill>
+                <a:latin typeface="BC Sans"/>
+                <a:ea typeface="Verdana" panose="020B0604030504040204" pitchFamily="34" charset="0"/>
+                <a:cs typeface="Verdana" panose="020B0604030504040204" pitchFamily="34" charset="0"/>
+              </a:rPr>
+              <a:t>ResidenceName</a:t>
+            </a:r>
+            <a:r>
+              <a:rPr lang="en-US" b="1" dirty="0">
+                <a:solidFill>
+                  <a:srgbClr val="3B305B"/>
+                </a:solidFill>
+                <a:latin typeface="BC Sans"/>
+                <a:ea typeface="Verdana" panose="020B0604030504040204" pitchFamily="34" charset="0"/>
+                <a:cs typeface="Verdana" panose="020B0604030504040204" pitchFamily="34" charset="0"/>
+              </a:rPr>
+              <a:t>}}</a:t>
+            </a:r>
+          </a:p>
+          <a:p>
+            <a:pPr>
+              <a:lnSpc>
+                <a:spcPct val="200000"/>
+              </a:lnSpc>
+              <a:spcAft>
+                <a:spcPts val="300"/>
+              </a:spcAft>
+            </a:pPr>
+            <a:r>
+              <a:rPr lang="en-US" sz="1400" b="1" dirty="0">
+                <a:solidFill>
+                  <a:srgbClr val="3B305B"/>
+                </a:solidFill>
+                <a:latin typeface="BC Sans"/>
+                <a:ea typeface="Verdana" panose="020B0604030504040204" pitchFamily="34" charset="0"/>
+                <a:cs typeface="Verdana" panose="020B0604030504040204" pitchFamily="34" charset="0"/>
+              </a:rPr>
+              <a:t>{{</a:t>
+            </a:r>
+            <a:r>
+              <a:rPr lang="en-US" sz="1400" b="1" dirty="0" err="1">
+                <a:solidFill>
+                  <a:srgbClr val="3B305B"/>
+                </a:solidFill>
+                <a:latin typeface="BC Sans"/>
+                <a:ea typeface="Verdana" panose="020B0604030504040204" pitchFamily="34" charset="0"/>
+                <a:cs typeface="Verdana" panose="020B0604030504040204" pitchFamily="34" charset="0"/>
+              </a:rPr>
+              <a:t>RegistrantName</a:t>
+            </a:r>
+            <a:r>
+              <a:rPr lang="en-US" sz="1400" b="1" dirty="0">
+                <a:solidFill>
+                  <a:srgbClr val="3B305B"/>
+                </a:solidFill>
+                <a:latin typeface="BC Sans"/>
+                <a:ea typeface="Verdana" panose="020B0604030504040204" pitchFamily="34" charset="0"/>
+                <a:cs typeface="Verdana" panose="020B0604030504040204" pitchFamily="34" charset="0"/>
+              </a:rPr>
+              <a:t>}}</a:t>
+            </a:r>
+          </a:p>
           <a:p>
             <a:pPr>
               <a:lnSpc>
@@ -3924,7 +4010,7 @@
               </a:spcAft>
             </a:pPr>
             <a:r>
-              <a:rPr lang="en-US" sz="2200" b="1" dirty="0">
+              <a:rPr lang="en-US" sz="1200" dirty="0">
                 <a:solidFill>
                   <a:srgbClr val="3B305B"/>
                 </a:solidFill>
@@ -3935,7 +4021,7 @@
               <a:t>{{</a:t>
             </a:r>
             <a:r>
-              <a:rPr lang="en-US" sz="2200" b="1" dirty="0" err="1">
+              <a:rPr lang="en-US" sz="1200" dirty="0" err="1">
                 <a:solidFill>
                   <a:srgbClr val="3B305B"/>
                 </a:solidFill>
@@ -3943,10 +4029,10 @@
                 <a:ea typeface="Verdana" panose="020B0604030504040204" pitchFamily="34" charset="0"/>
                 <a:cs typeface="Verdana" panose="020B0604030504040204" pitchFamily="34" charset="0"/>
               </a:rPr>
-              <a:t>ResidenceName</a:t>
-            </a:r>
-            <a:r>
-              <a:rPr lang="en-US" sz="2200" b="1" dirty="0">
+              <a:t>ResidenceAddress</a:t>
+            </a:r>
+            <a:r>
+              <a:rPr lang="en-US" sz="1200" dirty="0">
                 <a:solidFill>
                   <a:srgbClr val="3B305B"/>
                 </a:solidFill>
@@ -3966,8 +4052,80 @@
                 <a:spcPts val="300"/>
               </a:spcAft>
             </a:pPr>
-            <a:r>
-              <a:rPr lang="en-US" sz="2000" b="1" dirty="0">
+            <a:endParaRPr lang="en-US" sz="1200" dirty="0">
+              <a:solidFill>
+                <a:srgbClr val="3B305B"/>
+              </a:solidFill>
+              <a:latin typeface="BC Sans"/>
+              <a:ea typeface="Verdana" panose="020B0604030504040204" pitchFamily="34" charset="0"/>
+              <a:cs typeface="Verdana" panose="020B0604030504040204" pitchFamily="34" charset="0"/>
+            </a:endParaRPr>
+          </a:p>
+          <a:p>
+            <a:pPr>
+              <a:lnSpc>
+                <a:spcPct val="150000"/>
+              </a:lnSpc>
+              <a:spcAft>
+                <a:spcPts val="300"/>
+              </a:spcAft>
+            </a:pPr>
+            <a:r>
+              <a:rPr lang="en-US" sz="1400" dirty="0">
+                <a:solidFill>
+                  <a:schemeClr val="accent2"/>
+                </a:solidFill>
+                <a:latin typeface="BC Sans"/>
+                <a:ea typeface="Verdana" panose="020B0604030504040204" pitchFamily="34" charset="0"/>
+                <a:cs typeface="Verdana" panose="020B0604030504040204" pitchFamily="34" charset="0"/>
+              </a:rPr>
+              <a:t>Class: {{</a:t>
+            </a:r>
+            <a:r>
+              <a:rPr lang="en-US" sz="1400" dirty="0" err="1">
+                <a:solidFill>
+                  <a:schemeClr val="accent2"/>
+                </a:solidFill>
+                <a:latin typeface="BC Sans"/>
+                <a:ea typeface="Verdana" panose="020B0604030504040204" pitchFamily="34" charset="0"/>
+                <a:cs typeface="Verdana" panose="020B0604030504040204" pitchFamily="34" charset="0"/>
+              </a:rPr>
+              <a:t>ResidenceClassType</a:t>
+            </a:r>
+            <a:r>
+              <a:rPr lang="en-US" sz="1400" dirty="0">
+                <a:solidFill>
+                  <a:schemeClr val="accent2"/>
+                </a:solidFill>
+                <a:latin typeface="BC Sans"/>
+                <a:ea typeface="Verdana" panose="020B0604030504040204" pitchFamily="34" charset="0"/>
+                <a:cs typeface="Verdana" panose="020B0604030504040204" pitchFamily="34" charset="0"/>
+              </a:rPr>
+              <a:t>}}</a:t>
+            </a:r>
+          </a:p>
+          <a:p>
+            <a:pPr>
+              <a:lnSpc>
+                <a:spcPct val="150000"/>
+              </a:lnSpc>
+              <a:spcAft>
+                <a:spcPts val="300"/>
+              </a:spcAft>
+            </a:pPr>
+            <a:r>
+              <a:rPr lang="en-US" sz="1400" dirty="0">
+                <a:solidFill>
+                  <a:srgbClr val="3B305B"/>
+                </a:solidFill>
+                <a:latin typeface="BC Sans"/>
+                <a:ea typeface="Verdana" panose="020B0604030504040204" pitchFamily="34" charset="0"/>
+                <a:cs typeface="Verdana" panose="020B0604030504040204" pitchFamily="34" charset="0"/>
+              </a:rPr>
+              <a:t>Number of units: </a:t>
+            </a:r>
+            <a:r>
+              <a:rPr lang="en-US" sz="1400" b="1" dirty="0">
                 <a:solidFill>
                   <a:srgbClr val="3B305B"/>
                 </a:solidFill>
@@ -3978,7 +4136,7 @@
               <a:t>{{</a:t>
             </a:r>
             <a:r>
-              <a:rPr lang="en-US" sz="2000" b="1" dirty="0" err="1">
+              <a:rPr lang="en-US" sz="1400" b="1" dirty="0" err="1">
                 <a:solidFill>
                   <a:srgbClr val="3B305B"/>
                 </a:solidFill>
@@ -3986,10 +4144,10 @@
                 <a:ea typeface="Verdana" panose="020B0604030504040204" pitchFamily="34" charset="0"/>
                 <a:cs typeface="Verdana" panose="020B0604030504040204" pitchFamily="34" charset="0"/>
               </a:rPr>
-              <a:t>RegistrantName</a:t>
-            </a:r>
-            <a:r>
-              <a:rPr lang="en-US" sz="2000" b="1" dirty="0">
+              <a:t>TotalUnits</a:t>
+            </a:r>
+            <a:r>
+              <a:rPr lang="en-US" sz="1400" b="1" dirty="0">
                 <a:solidFill>
                   <a:srgbClr val="3B305B"/>
                 </a:solidFill>
@@ -4003,136 +4161,7 @@
           <a:p>
             <a:pPr>
               <a:lnSpc>
-                <a:spcPct val="110000"/>
-              </a:lnSpc>
-              <a:spcAft>
-                <a:spcPts val="300"/>
-              </a:spcAft>
-            </a:pPr>
-            <a:r>
-              <a:rPr lang="en-US" sz="1600" dirty="0">
-                <a:solidFill>
-                  <a:srgbClr val="3B305B"/>
-                </a:solidFill>
-                <a:latin typeface="BC Sans"/>
-                <a:ea typeface="Verdana" panose="020B0604030504040204" pitchFamily="34" charset="0"/>
-                <a:cs typeface="Verdana" panose="020B0604030504040204" pitchFamily="34" charset="0"/>
-              </a:rPr>
-              <a:t>{{</a:t>
-            </a:r>
-            <a:r>
-              <a:rPr lang="en-US" sz="1600" dirty="0" err="1">
-                <a:solidFill>
-                  <a:srgbClr val="3B305B"/>
-                </a:solidFill>
-                <a:latin typeface="BC Sans"/>
-                <a:ea typeface="Verdana" panose="020B0604030504040204" pitchFamily="34" charset="0"/>
-                <a:cs typeface="Verdana" panose="020B0604030504040204" pitchFamily="34" charset="0"/>
-              </a:rPr>
-              <a:t>ResidenceAddress</a:t>
-            </a:r>
-            <a:r>
-              <a:rPr lang="en-US" sz="1600" dirty="0">
-                <a:solidFill>
-                  <a:srgbClr val="3B305B"/>
-                </a:solidFill>
-                <a:latin typeface="BC Sans"/>
-                <a:ea typeface="Verdana" panose="020B0604030504040204" pitchFamily="34" charset="0"/>
-                <a:cs typeface="Verdana" panose="020B0604030504040204" pitchFamily="34" charset="0"/>
-              </a:rPr>
-              <a:t>}}</a:t>
-            </a:r>
-          </a:p>
-          <a:p>
-            <a:pPr>
-              <a:lnSpc>
-                <a:spcPct val="110000"/>
-              </a:lnSpc>
-              <a:spcAft>
-                <a:spcPts val="300"/>
-              </a:spcAft>
-            </a:pPr>
-            <a:r>
-              <a:rPr lang="en-US" sz="1400" dirty="0">
-                <a:solidFill>
-                  <a:schemeClr val="accent2"/>
-                </a:solidFill>
-                <a:latin typeface="BC Sans"/>
-                <a:ea typeface="Verdana" panose="020B0604030504040204" pitchFamily="34" charset="0"/>
-                <a:cs typeface="Verdana" panose="020B0604030504040204" pitchFamily="34" charset="0"/>
-              </a:rPr>
-              <a:t>Class: {{</a:t>
-            </a:r>
-            <a:r>
-              <a:rPr lang="en-US" sz="1400" dirty="0" err="1">
-                <a:solidFill>
-                  <a:schemeClr val="accent2"/>
-                </a:solidFill>
-                <a:latin typeface="BC Sans"/>
-                <a:ea typeface="Verdana" panose="020B0604030504040204" pitchFamily="34" charset="0"/>
-                <a:cs typeface="Verdana" panose="020B0604030504040204" pitchFamily="34" charset="0"/>
-              </a:rPr>
-              <a:t>ResidenceClassType</a:t>
-            </a:r>
-            <a:r>
-              <a:rPr lang="en-US" sz="1400" dirty="0">
-                <a:solidFill>
-                  <a:schemeClr val="accent2"/>
-                </a:solidFill>
-                <a:latin typeface="BC Sans"/>
-                <a:ea typeface="Verdana" panose="020B0604030504040204" pitchFamily="34" charset="0"/>
-                <a:cs typeface="Verdana" panose="020B0604030504040204" pitchFamily="34" charset="0"/>
-              </a:rPr>
-              <a:t>}}</a:t>
-            </a:r>
-          </a:p>
-          <a:p>
-            <a:pPr>
-              <a:lnSpc>
-                <a:spcPct val="110000"/>
-              </a:lnSpc>
-              <a:spcAft>
-                <a:spcPts val="300"/>
-              </a:spcAft>
-            </a:pPr>
-            <a:r>
-              <a:rPr lang="en-US" sz="1400" dirty="0">
-                <a:solidFill>
-                  <a:srgbClr val="3B305B"/>
-                </a:solidFill>
-                <a:latin typeface="BC Sans"/>
-                <a:ea typeface="Verdana" panose="020B0604030504040204" pitchFamily="34" charset="0"/>
-                <a:cs typeface="Verdana" panose="020B0604030504040204" pitchFamily="34" charset="0"/>
-              </a:rPr>
-              <a:t>Number of units: {{</a:t>
-            </a:r>
-            <a:r>
-              <a:rPr lang="en-US" sz="1400" dirty="0" err="1">
-                <a:solidFill>
-                  <a:srgbClr val="3B305B"/>
-                </a:solidFill>
-                <a:latin typeface="BC Sans"/>
-                <a:ea typeface="Verdana" panose="020B0604030504040204" pitchFamily="34" charset="0"/>
-                <a:cs typeface="Verdana" panose="020B0604030504040204" pitchFamily="34" charset="0"/>
-              </a:rPr>
-              <a:t>TotalUnits</a:t>
-            </a:r>
-            <a:r>
-              <a:rPr lang="en-US" sz="1400" dirty="0">
-                <a:solidFill>
-                  <a:srgbClr val="3B305B"/>
-                </a:solidFill>
-                <a:latin typeface="BC Sans"/>
-                <a:ea typeface="Verdana" panose="020B0604030504040204" pitchFamily="34" charset="0"/>
-                <a:cs typeface="Verdana" panose="020B0604030504040204" pitchFamily="34" charset="0"/>
-              </a:rPr>
-              <a:t>}}</a:t>
-            </a:r>
-          </a:p>
-          <a:p>
-            <a:pPr>
-              <a:lnSpc>
-                <a:spcPct val="110000"/>
+                <a:spcPct val="150000"/>
               </a:lnSpc>
               <a:spcBef>
                 <a:spcPts val="600"/>
@@ -4174,7 +4203,7 @@
           <a:p>
             <a:pPr>
               <a:lnSpc>
-                <a:spcPct val="110000"/>
+                <a:spcPct val="150000"/>
               </a:lnSpc>
               <a:spcBef>
                 <a:spcPts val="600"/>
@@ -4254,8 +4283,8 @@
         </p:nvSpPr>
         <p:spPr>
           <a:xfrm>
-            <a:off x="1688558" y="619732"/>
-            <a:ext cx="8469856" cy="430887"/>
+            <a:off x="1512000" y="352357"/>
+            <a:ext cx="8380800" cy="430887"/>
           </a:xfrm>
           <a:prstGeom prst="rect">
             <a:avLst/>

</xml_diff>